<commit_message>
Reposition Fly456 deck around named monitoring and cabin products.
Drop LatAm/EU framing; lead with origin/destination/dates/max price,
Telegram alerts to book fast, and Economy + Business products.

Co-authored-by: Emiliano Tichauer <Parvusmedia@users.noreply.github.com>
</commit_message>
<xml_diff>
--- a/Fly456_Kima_OnePager.pptx
+++ b/Fly456_Kima_OnePager.pptx
@@ -3230,7 +3230,7 @@
         </p:nvSpPr>
         <p:spPr>
           <a:xfrm>
-            <a:off x="640080" y="1188720"/>
+            <a:off x="640080" y="1097280"/>
             <a:ext cx="10058400" cy="365760"/>
           </a:xfrm>
           <a:prstGeom prst="rect">
@@ -3253,7 +3253,7 @@
               </a:defRPr>
             </a:pPr>
             <a:r>
-              <a:t>PRE-SEED  ·  CONSUMER TRAVEL  ·  TELEGRAM-NATIVE</a:t>
+              <a:t>PRE-SEED  ·  FLIGHT MONITORING  ·  TELEGRAM ALERTS</a:t>
             </a:r>
           </a:p>
         </p:txBody>
@@ -3266,7 +3266,7 @@
         </p:nvSpPr>
         <p:spPr>
           <a:xfrm>
-            <a:off x="640080" y="1737360"/>
+            <a:off x="640080" y="1645920"/>
             <a:ext cx="10058400" cy="822960"/>
           </a:xfrm>
           <a:prstGeom prst="rect">
@@ -3302,8 +3302,8 @@
         </p:nvSpPr>
         <p:spPr>
           <a:xfrm>
-            <a:off x="640080" y="2651760"/>
-            <a:ext cx="10058400" cy="914400"/>
+            <a:off x="640080" y="2560320"/>
+            <a:ext cx="10058400" cy="1097280"/>
           </a:xfrm>
           <a:prstGeom prst="rect">
             <a:avLst/>
@@ -3325,11 +3325,11 @@
               </a:defRPr>
             </a:pPr>
             <a:r>
-              <a:t>Cheap-flight opportunities EU/US to LatAm.</a:t>
+              <a:t>You set origin, destination, dates and max price.</a:t>
             </a:r>
             <a:br/>
             <a:r>
-              <a:t>Free Telegram channels + paid route alerts.</a:t>
+              <a:t>We monitor flights and notify you on Telegram — so you can book fast.</a:t>
             </a:r>
           </a:p>
         </p:txBody>
@@ -3342,7 +3342,7 @@
         </p:nvSpPr>
         <p:spPr>
           <a:xfrm>
-            <a:off x="640080" y="3840480"/>
+            <a:off x="640080" y="3931920"/>
             <a:ext cx="10058400" cy="365760"/>
           </a:xfrm>
           <a:prstGeom prst="rect">
@@ -3365,7 +3365,7 @@
               </a:defRPr>
             </a:pPr>
             <a:r>
-              <a:t>Asking: ~€150k pre-seed  ·  fly456.com</a:t>
+              <a:t>Two products: Economy cabin  ·  Business cabin</a:t>
             </a:r>
           </a:p>
         </p:txBody>
@@ -3378,7 +3378,7 @@
         </p:nvSpPr>
         <p:spPr>
           <a:xfrm>
-            <a:off x="640080" y="4754880"/>
+            <a:off x="640080" y="4572000"/>
             <a:ext cx="10058400" cy="365760"/>
           </a:xfrm>
           <a:prstGeom prst="rect">
@@ -3393,6 +3393,42 @@
           <a:lstStyle/>
           <a:p>
             <a:pPr algn="l">
+              <a:defRPr sz="1500" b="1">
+                <a:solidFill>
+                  <a:srgbClr val="A0B4BE"/>
+                </a:solidFill>
+                <a:latin typeface="Calibri"/>
+              </a:defRPr>
+            </a:pPr>
+            <a:r>
+              <a:t>Asking: ~€150k pre-seed  ·  fly456.com  ·  @fly456bot</a:t>
+            </a:r>
+          </a:p>
+        </p:txBody>
+      </p:sp>
+      <p:sp>
+        <p:nvSpPr>
+          <p:cNvPr id="10" name="TextBox 9"/>
+          <p:cNvSpPr txBox="1"/>
+          <p:nvPr/>
+        </p:nvSpPr>
+        <p:spPr>
+          <a:xfrm>
+            <a:off x="640080" y="5120640"/>
+            <a:ext cx="10058400" cy="365760"/>
+          </a:xfrm>
+          <a:prstGeom prst="rect">
+            <a:avLst/>
+          </a:prstGeom>
+          <a:noFill/>
+        </p:spPr>
+        <p:txBody>
+          <a:bodyPr wrap="square">
+            <a:spAutoFit/>
+          </a:bodyPr>
+          <a:lstStyle/>
+          <a:p>
+            <a:pPr algn="l">
               <a:defRPr sz="1400" b="0">
                 <a:solidFill>
                   <a:srgbClr val="A0B4BE"/>
@@ -3401,14 +3437,14 @@
               </a:defRPr>
             </a:pPr>
             <a:r>
-              <a:t>Emiliano Tichauer  ·  Founder  ·  Parvus Media / Fly456</a:t>
-            </a:r>
-          </a:p>
-        </p:txBody>
-      </p:sp>
-      <p:sp>
-        <p:nvSpPr>
-          <p:cNvPr id="10" name="TextBox 9"/>
+              <a:t>Emiliano Tichauer  ·  Founder</a:t>
+            </a:r>
+          </a:p>
+        </p:txBody>
+      </p:sp>
+      <p:sp>
+        <p:nvSpPr>
+          <p:cNvPr id="11" name="TextBox 10"/>
           <p:cNvSpPr txBox="1"/>
           <p:nvPr/>
         </p:nvSpPr>
@@ -3728,7 +3764,7 @@
               </a:defRPr>
             </a:pPr>
             <a:r>
-              <a:t>Good fares to LatAm disappear before people see them</a:t>
+              <a:t>Good fares disappear before travelers can act</a:t>
             </a:r>
           </a:p>
         </p:txBody>
@@ -3767,7 +3803,7 @@
               </a:defRPr>
             </a:pPr>
             <a:r>
-              <a:t>•  Diaspora and leisure travelers watch dozens of groups and still miss deals.</a:t>
+              <a:t>•  Flight prices move in hours. Checking sites manually is slow and easy to miss.</a:t>
             </a:r>
           </a:p>
           <a:p>
@@ -3783,7 +3819,7 @@
               </a:defRPr>
             </a:pPr>
             <a:r>
-              <a:t>•  Airline and OTA prices move in hours; generic alerts are noisy.</a:t>
+              <a:t>•  Generic deal feeds are noisy — they are not your route, dates or budget.</a:t>
             </a:r>
           </a:p>
           <a:p>
@@ -3799,7 +3835,7 @@
               </a:defRPr>
             </a:pPr>
             <a:r>
-              <a:t>•  Existing flight clubs are crowded, slow, or not focused on LatAm corridors.</a:t>
+              <a:t>•  By the time you see a fare, seats and price are often already gone.</a:t>
             </a:r>
           </a:p>
         </p:txBody>
@@ -4090,7 +4126,7 @@
               </a:defRPr>
             </a:pPr>
             <a:r>
-              <a:t>Detect opportunities. Alert fast. Stay on Telegram.</a:t>
+              <a:t>Named monitoring + Telegram alert to book fast</a:t>
             </a:r>
           </a:p>
         </p:txBody>
@@ -4103,8 +4139,8 @@
         </p:nvSpPr>
         <p:spPr>
           <a:xfrm>
-            <a:off x="457200" y="1920240"/>
-            <a:ext cx="3566160" cy="3474720"/>
+            <a:off x="457200" y="1828800"/>
+            <a:ext cx="3657600" cy="3840480"/>
           </a:xfrm>
           <a:prstGeom prst="roundRect">
             <a:avLst/>
@@ -4146,8 +4182,8 @@
         </p:nvSpPr>
         <p:spPr>
           <a:xfrm>
-            <a:off x="457200" y="1920240"/>
-            <a:ext cx="3566160" cy="54864"/>
+            <a:off x="457200" y="1828800"/>
+            <a:ext cx="3657600" cy="54864"/>
           </a:xfrm>
           <a:prstGeom prst="rect">
             <a:avLst/>
@@ -4189,8 +4225,8 @@
         </p:nvSpPr>
         <p:spPr>
           <a:xfrm>
-            <a:off x="640080" y="2103120"/>
-            <a:ext cx="3200400" cy="320040"/>
+            <a:off x="640080" y="2011680"/>
+            <a:ext cx="3291840" cy="320040"/>
           </a:xfrm>
           <a:prstGeom prst="rect">
             <a:avLst/>
@@ -4212,7 +4248,7 @@
               </a:defRPr>
             </a:pPr>
             <a:r>
-              <a:t>Free</a:t>
+              <a:t>You define the flight</a:t>
             </a:r>
           </a:p>
         </p:txBody>
@@ -4225,8 +4261,8 @@
         </p:nvSpPr>
         <p:spPr>
           <a:xfrm>
-            <a:off x="640080" y="2468880"/>
-            <a:ext cx="3200400" cy="2743200"/>
+            <a:off x="640080" y="2377440"/>
+            <a:ext cx="3291840" cy="3108960"/>
           </a:xfrm>
           <a:prstGeom prst="rect">
             <a:avLst/>
@@ -4251,7 +4287,7 @@
               </a:defRPr>
             </a:pPr>
             <a:r>
-              <a:t>Public Telegram channels</a:t>
+              <a:t>Origin</a:t>
             </a:r>
           </a:p>
           <a:p>
@@ -4267,7 +4303,7 @@
               </a:defRPr>
             </a:pPr>
             <a:r>
-              <a:t>by origin / destination</a:t>
+              <a:t>Destination</a:t>
             </a:r>
           </a:p>
           <a:p>
@@ -4283,7 +4319,7 @@
               </a:defRPr>
             </a:pPr>
             <a:r>
-              <a:t>EU/US → LatAm routes</a:t>
+              <a:t>Dates</a:t>
             </a:r>
           </a:p>
           <a:p>
@@ -4299,7 +4335,36 @@
               </a:defRPr>
             </a:pPr>
             <a:r>
-              <a:t>Discovery engine</a:t>
+              <a:t>Maximum price</a:t>
+            </a:r>
+          </a:p>
+          <a:p>
+            <a:pPr>
+              <a:spcAft>
+                <a:spcPts val="400"/>
+              </a:spcAft>
+              <a:defRPr sz="1300">
+                <a:solidFill>
+                  <a:srgbClr val="19232D"/>
+                </a:solidFill>
+                <a:latin typeface="Calibri"/>
+              </a:defRPr>
+            </a:pPr>
+          </a:p>
+          <a:p>
+            <a:pPr>
+              <a:spcAft>
+                <a:spcPts val="400"/>
+              </a:spcAft>
+              <a:defRPr sz="1300">
+                <a:solidFill>
+                  <a:srgbClr val="19232D"/>
+                </a:solidFill>
+                <a:latin typeface="Calibri"/>
+              </a:defRPr>
+            </a:pPr>
+            <a:r>
+              <a:t>Fly456 watches that exact brief.</a:t>
             </a:r>
           </a:p>
         </p:txBody>
@@ -4312,8 +4377,8 @@
         </p:nvSpPr>
         <p:spPr>
           <a:xfrm>
-            <a:off x="4297680" y="1920240"/>
-            <a:ext cx="3566160" cy="3474720"/>
+            <a:off x="4343400" y="1828800"/>
+            <a:ext cx="3657600" cy="3840480"/>
           </a:xfrm>
           <a:prstGeom prst="roundRect">
             <a:avLst/>
@@ -4355,8 +4420,8 @@
         </p:nvSpPr>
         <p:spPr>
           <a:xfrm>
-            <a:off x="4297680" y="1920240"/>
-            <a:ext cx="3566160" cy="54864"/>
+            <a:off x="4343400" y="1828800"/>
+            <a:ext cx="3657600" cy="54864"/>
           </a:xfrm>
           <a:prstGeom prst="rect">
             <a:avLst/>
@@ -4398,8 +4463,8 @@
         </p:nvSpPr>
         <p:spPr>
           <a:xfrm>
-            <a:off x="4480560" y="2103120"/>
-            <a:ext cx="3200400" cy="320040"/>
+            <a:off x="4526280" y="2011680"/>
+            <a:ext cx="3291840" cy="320040"/>
           </a:xfrm>
           <a:prstGeom prst="rect">
             <a:avLst/>
@@ -4421,7 +4486,7 @@
               </a:defRPr>
             </a:pPr>
             <a:r>
-              <a:t>Premium</a:t>
+              <a:t>We notify on Telegram</a:t>
             </a:r>
           </a:p>
         </p:txBody>
@@ -4434,8 +4499,8 @@
         </p:nvSpPr>
         <p:spPr>
           <a:xfrm>
-            <a:off x="4480560" y="2468880"/>
-            <a:ext cx="3200400" cy="2743200"/>
+            <a:off x="4526280" y="2377440"/>
+            <a:ext cx="3291840" cy="3108960"/>
           </a:xfrm>
           <a:prstGeom prst="rect">
             <a:avLst/>
@@ -4460,7 +4525,7 @@
               </a:defRPr>
             </a:pPr>
             <a:r>
-              <a:t>Personal route alerts</a:t>
+              <a:t>Alert lands in your Telegram inbox</a:t>
             </a:r>
           </a:p>
           <a:p>
@@ -4476,7 +4541,7 @@
               </a:defRPr>
             </a:pPr>
             <a:r>
-              <a:t>Origin + dest + dates</a:t>
+              <a:t>via @fly456bot</a:t>
             </a:r>
           </a:p>
           <a:p>
@@ -4492,7 +4557,7 @@
               </a:defRPr>
             </a:pPr>
             <a:r>
-              <a:t>Max price threshold</a:t>
+              <a:t>Built to help you reserve fast</a:t>
             </a:r>
           </a:p>
           <a:p>
@@ -4508,7 +4573,36 @@
               </a:defRPr>
             </a:pPr>
             <a:r>
-              <a:t>Inbox via @fly456bot</a:t>
+              <a:t>before the fare moves again</a:t>
+            </a:r>
+          </a:p>
+          <a:p>
+            <a:pPr>
+              <a:spcAft>
+                <a:spcPts val="400"/>
+              </a:spcAft>
+              <a:defRPr sz="1300">
+                <a:solidFill>
+                  <a:srgbClr val="19232D"/>
+                </a:solidFill>
+                <a:latin typeface="Calibri"/>
+              </a:defRPr>
+            </a:pPr>
+          </a:p>
+          <a:p>
+            <a:pPr>
+              <a:spcAft>
+                <a:spcPts val="400"/>
+              </a:spcAft>
+              <a:defRPr sz="1300">
+                <a:solidFill>
+                  <a:srgbClr val="19232D"/>
+                </a:solidFill>
+                <a:latin typeface="Calibri"/>
+              </a:defRPr>
+            </a:pPr>
+            <a:r>
+              <a:t>We do not sell tickets.</a:t>
             </a:r>
           </a:p>
         </p:txBody>
@@ -4521,8 +4615,8 @@
         </p:nvSpPr>
         <p:spPr>
           <a:xfrm>
-            <a:off x="8138160" y="1920240"/>
-            <a:ext cx="3566160" cy="3474720"/>
+            <a:off x="8229600" y="1828800"/>
+            <a:ext cx="3474720" cy="3840480"/>
           </a:xfrm>
           <a:prstGeom prst="roundRect">
             <a:avLst/>
@@ -4564,8 +4658,8 @@
         </p:nvSpPr>
         <p:spPr>
           <a:xfrm>
-            <a:off x="8138160" y="1920240"/>
-            <a:ext cx="3566160" cy="54864"/>
+            <a:off x="8229600" y="1828800"/>
+            <a:ext cx="3474720" cy="54864"/>
           </a:xfrm>
           <a:prstGeom prst="rect">
             <a:avLst/>
@@ -4607,8 +4701,8 @@
         </p:nvSpPr>
         <p:spPr>
           <a:xfrm>
-            <a:off x="8321040" y="2103120"/>
-            <a:ext cx="3200400" cy="320040"/>
+            <a:off x="8412480" y="2011680"/>
+            <a:ext cx="3108960" cy="320040"/>
           </a:xfrm>
           <a:prstGeom prst="rect">
             <a:avLst/>
@@ -4630,7 +4724,7 @@
               </a:defRPr>
             </a:pPr>
             <a:r>
-              <a:t>Not us</a:t>
+              <a:t>Two cabin products</a:t>
             </a:r>
           </a:p>
         </p:txBody>
@@ -4643,8 +4737,8 @@
         </p:nvSpPr>
         <p:spPr>
           <a:xfrm>
-            <a:off x="8321040" y="2468880"/>
-            <a:ext cx="3200400" cy="2743200"/>
+            <a:off x="8412480" y="2377440"/>
+            <a:ext cx="3108960" cy="3108960"/>
           </a:xfrm>
           <a:prstGeom prst="rect">
             <a:avLst/>
@@ -4669,7 +4763,7 @@
               </a:defRPr>
             </a:pPr>
             <a:r>
-              <a:t>We do not sell tickets</a:t>
+              <a:t>Economy — monitor economy</a:t>
             </a:r>
           </a:p>
           <a:p>
@@ -4685,7 +4779,7 @@
               </a:defRPr>
             </a:pPr>
             <a:r>
-              <a:t>User books with airline/OTA</a:t>
+              <a:t>cabin fares for your route</a:t>
             </a:r>
           </a:p>
           <a:p>
@@ -4700,9 +4794,6 @@
                 <a:latin typeface="Calibri"/>
               </a:defRPr>
             </a:pPr>
-            <a:r>
-              <a:t>We win on alerts + later</a:t>
-            </a:r>
           </a:p>
           <a:p>
             <a:pPr>
@@ -4717,7 +4808,52 @@
               </a:defRPr>
             </a:pPr>
             <a:r>
-              <a:t>affiliate / data upside</a:t>
+              <a:t>Business — monitor business</a:t>
+            </a:r>
+          </a:p>
+          <a:p>
+            <a:pPr>
+              <a:spcAft>
+                <a:spcPts val="400"/>
+              </a:spcAft>
+              <a:defRPr sz="1300">
+                <a:solidFill>
+                  <a:srgbClr val="19232D"/>
+                </a:solidFill>
+                <a:latin typeface="Calibri"/>
+              </a:defRPr>
+            </a:pPr>
+            <a:r>
+              <a:t>cabin fares for your route</a:t>
+            </a:r>
+          </a:p>
+          <a:p>
+            <a:pPr>
+              <a:spcAft>
+                <a:spcPts val="400"/>
+              </a:spcAft>
+              <a:defRPr sz="1300">
+                <a:solidFill>
+                  <a:srgbClr val="19232D"/>
+                </a:solidFill>
+                <a:latin typeface="Calibri"/>
+              </a:defRPr>
+            </a:pPr>
+          </a:p>
+          <a:p>
+            <a:pPr>
+              <a:spcAft>
+                <a:spcPts val="400"/>
+              </a:spcAft>
+              <a:defRPr sz="1300">
+                <a:solidFill>
+                  <a:srgbClr val="19232D"/>
+                </a:solidFill>
+                <a:latin typeface="Calibri"/>
+              </a:defRPr>
+            </a:pPr>
+            <a:r>
+              <a:t>Same alert logic, different cabin.</a:t>
             </a:r>
           </a:p>
         </p:txBody>
@@ -4972,7 +5108,7 @@
               </a:defRPr>
             </a:pPr>
             <a:r>
-              <a:t>TRACTION</a:t>
+              <a:t>PRODUCT</a:t>
             </a:r>
           </a:p>
         </p:txBody>
@@ -5008,21 +5144,107 @@
               </a:defRPr>
             </a:pPr>
             <a:r>
-              <a:t>Replace brackets with live numbers before sending</a:t>
-            </a:r>
-          </a:p>
-        </p:txBody>
-      </p:sp>
-      <p:sp>
-        <p:nvSpPr>
-          <p:cNvPr id="9" name="TextBox 8"/>
+              <a:t>Economy and Business — same monitoring, different cabin</a:t>
+            </a:r>
+          </a:p>
+        </p:txBody>
+      </p:sp>
+      <p:sp>
+        <p:nvSpPr>
+          <p:cNvPr id="9" name="Rounded Rectangle 8"/>
+          <p:cNvSpPr/>
+          <p:nvPr/>
+        </p:nvSpPr>
+        <p:spPr>
+          <a:xfrm>
+            <a:off x="457200" y="1828800"/>
+            <a:ext cx="5486400" cy="3840480"/>
+          </a:xfrm>
+          <a:prstGeom prst="roundRect">
+            <a:avLst/>
+          </a:prstGeom>
+          <a:solidFill>
+            <a:srgbClr val="F6F8FA"/>
+          </a:solidFill>
+          <a:ln>
+            <a:noFill/>
+          </a:ln>
+        </p:spPr>
+        <p:style>
+          <a:lnRef idx="1">
+            <a:schemeClr val="accent1"/>
+          </a:lnRef>
+          <a:fillRef idx="3">
+            <a:schemeClr val="accent1"/>
+          </a:fillRef>
+          <a:effectRef idx="2">
+            <a:schemeClr val="accent1"/>
+          </a:effectRef>
+          <a:fontRef idx="minor">
+            <a:schemeClr val="lt1"/>
+          </a:fontRef>
+        </p:style>
+        <p:txBody>
+          <a:bodyPr rtlCol="0" anchor="ctr"/>
+          <a:lstStyle/>
+          <a:p>
+            <a:pPr algn="ctr"/>
+          </a:p>
+        </p:txBody>
+      </p:sp>
+      <p:sp>
+        <p:nvSpPr>
+          <p:cNvPr id="10" name="Rectangle 9"/>
+          <p:cNvSpPr/>
+          <p:nvPr/>
+        </p:nvSpPr>
+        <p:spPr>
+          <a:xfrm>
+            <a:off x="457200" y="1828800"/>
+            <a:ext cx="5486400" cy="54864"/>
+          </a:xfrm>
+          <a:prstGeom prst="rect">
+            <a:avLst/>
+          </a:prstGeom>
+          <a:solidFill>
+            <a:srgbClr val="006E82"/>
+          </a:solidFill>
+          <a:ln>
+            <a:noFill/>
+          </a:ln>
+        </p:spPr>
+        <p:style>
+          <a:lnRef idx="1">
+            <a:schemeClr val="accent1"/>
+          </a:lnRef>
+          <a:fillRef idx="3">
+            <a:schemeClr val="accent1"/>
+          </a:fillRef>
+          <a:effectRef idx="2">
+            <a:schemeClr val="accent1"/>
+          </a:effectRef>
+          <a:fontRef idx="minor">
+            <a:schemeClr val="lt1"/>
+          </a:fontRef>
+        </p:style>
+        <p:txBody>
+          <a:bodyPr rtlCol="0" anchor="ctr"/>
+          <a:lstStyle/>
+          <a:p>
+            <a:pPr algn="ctr"/>
+          </a:p>
+        </p:txBody>
+      </p:sp>
+      <p:sp>
+        <p:nvSpPr>
+          <p:cNvPr id="11" name="TextBox 10"/>
           <p:cNvSpPr txBox="1"/>
           <p:nvPr/>
         </p:nvSpPr>
         <p:spPr>
           <a:xfrm>
-            <a:off x="548640" y="1828800"/>
-            <a:ext cx="10972800" cy="4114800"/>
+            <a:off x="640080" y="2011680"/>
+            <a:ext cx="5120640" cy="320040"/>
           </a:xfrm>
           <a:prstGeom prst="rect">
             <a:avLst/>
@@ -5035,97 +5257,30 @@
           </a:bodyPr>
           <a:lstStyle/>
           <a:p>
-            <a:pPr>
-              <a:spcAft>
-                <a:spcPts val="1000"/>
-              </a:spcAft>
-              <a:defRPr sz="1800">
-                <a:solidFill>
-                  <a:srgbClr val="19232D"/>
-                </a:solidFill>
-                <a:latin typeface="Calibri"/>
-              </a:defRPr>
-            </a:pPr>
-            <a:r>
-              <a:t>•  [N] free channels live on Telegram</a:t>
-            </a:r>
-          </a:p>
-          <a:p>
-            <a:pPr>
-              <a:spcAft>
-                <a:spcPts val="1000"/>
-              </a:spcAft>
-              <a:defRPr sz="1800">
-                <a:solidFill>
-                  <a:srgbClr val="19232D"/>
-                </a:solidFill>
-                <a:latin typeface="Calibri"/>
-              </a:defRPr>
-            </a:pPr>
-            <a:r>
-              <a:t>•  [M] members across channels (unique approx. [U])</a:t>
-            </a:r>
-          </a:p>
-          <a:p>
-            <a:pPr>
-              <a:spcAft>
-                <a:spcPts val="1000"/>
-              </a:spcAft>
-              <a:defRPr sz="1800">
-                <a:solidFill>
-                  <a:srgbClr val="19232D"/>
-                </a:solidFill>
-                <a:latin typeface="Calibri"/>
-              </a:defRPr>
-            </a:pPr>
-            <a:r>
-              <a:t>•  [P] paying Premium subscribers  ·  €[A] MRR</a:t>
-            </a:r>
-          </a:p>
-          <a:p>
-            <a:pPr>
-              <a:spcAft>
-                <a:spcPts val="1000"/>
-              </a:spcAft>
-              <a:defRPr sz="1800">
-                <a:solidFill>
-                  <a:srgbClr val="19232D"/>
-                </a:solidFill>
-                <a:latin typeface="Calibri"/>
-              </a:defRPr>
-            </a:pPr>
-            <a:r>
-              <a:t>•  Plans from ~€1 / alert / mo  ·  Stripe checkout in Telegram</a:t>
-            </a:r>
-          </a:p>
-          <a:p>
-            <a:pPr>
-              <a:spcAft>
-                <a:spcPts val="1000"/>
-              </a:spcAft>
-              <a:defRPr sz="1800">
-                <a:solidFill>
-                  <a:srgbClr val="19232D"/>
-                </a:solidFill>
-                <a:latin typeface="Calibri"/>
-              </a:defRPr>
-            </a:pPr>
-            <a:r>
-              <a:t>•  Product live: fly456.com + @fly456bot</a:t>
-            </a:r>
-          </a:p>
-        </p:txBody>
-      </p:sp>
-      <p:sp>
-        <p:nvSpPr>
-          <p:cNvPr id="10" name="TextBox 9"/>
+            <a:pPr algn="l">
+              <a:defRPr sz="1600" b="1">
+                <a:solidFill>
+                  <a:srgbClr val="0F1E2D"/>
+                </a:solidFill>
+                <a:latin typeface="Calibri"/>
+              </a:defRPr>
+            </a:pPr>
+            <a:r>
+              <a:t>Fly456 Economy</a:t>
+            </a:r>
+          </a:p>
+        </p:txBody>
+      </p:sp>
+      <p:sp>
+        <p:nvSpPr>
+          <p:cNvPr id="12" name="TextBox 11"/>
           <p:cNvSpPr txBox="1"/>
           <p:nvPr/>
         </p:nvSpPr>
         <p:spPr>
           <a:xfrm>
-            <a:off x="548640" y="5943600"/>
-            <a:ext cx="10972800" cy="365760"/>
+            <a:off x="640080" y="2377440"/>
+            <a:ext cx="5120640" cy="3108960"/>
           </a:xfrm>
           <a:prstGeom prst="rect">
             <a:avLst/>
@@ -5138,16 +5293,308 @@
           </a:bodyPr>
           <a:lstStyle/>
           <a:p>
+            <a:pPr>
+              <a:spcAft>
+                <a:spcPts val="400"/>
+              </a:spcAft>
+              <a:defRPr sz="1300">
+                <a:solidFill>
+                  <a:srgbClr val="19232D"/>
+                </a:solidFill>
+                <a:latin typeface="Calibri"/>
+              </a:defRPr>
+            </a:pPr>
+            <a:r>
+              <a:t>Monitors economy-cabin opportunities</a:t>
+            </a:r>
+          </a:p>
+          <a:p>
+            <a:pPr>
+              <a:spcAft>
+                <a:spcPts val="400"/>
+              </a:spcAft>
+              <a:defRPr sz="1300">
+                <a:solidFill>
+                  <a:srgbClr val="19232D"/>
+                </a:solidFill>
+                <a:latin typeface="Calibri"/>
+              </a:defRPr>
+            </a:pPr>
+            <a:r>
+              <a:t>Alert = origin + destination + dates + max price</a:t>
+            </a:r>
+          </a:p>
+          <a:p>
+            <a:pPr>
+              <a:spcAft>
+                <a:spcPts val="400"/>
+              </a:spcAft>
+              <a:defRPr sz="1300">
+                <a:solidFill>
+                  <a:srgbClr val="19232D"/>
+                </a:solidFill>
+                <a:latin typeface="Calibri"/>
+              </a:defRPr>
+            </a:pPr>
+            <a:r>
+              <a:t>Telegram notification when a match appears</a:t>
+            </a:r>
+          </a:p>
+          <a:p>
+            <a:pPr>
+              <a:spcAft>
+                <a:spcPts val="400"/>
+              </a:spcAft>
+              <a:defRPr sz="1300">
+                <a:solidFill>
+                  <a:srgbClr val="19232D"/>
+                </a:solidFill>
+                <a:latin typeface="Calibri"/>
+              </a:defRPr>
+            </a:pPr>
+            <a:r>
+              <a:t>For leisure and price-sensitive travelers</a:t>
+            </a:r>
+          </a:p>
+          <a:p>
+            <a:pPr>
+              <a:spcAft>
+                <a:spcPts val="400"/>
+              </a:spcAft>
+              <a:defRPr sz="1300">
+                <a:solidFill>
+                  <a:srgbClr val="19232D"/>
+                </a:solidFill>
+                <a:latin typeface="Calibri"/>
+              </a:defRPr>
+            </a:pPr>
+            <a:r>
+              <a:t>who need speed, not another search tab</a:t>
+            </a:r>
+          </a:p>
+        </p:txBody>
+      </p:sp>
+      <p:sp>
+        <p:nvSpPr>
+          <p:cNvPr id="13" name="Rounded Rectangle 12"/>
+          <p:cNvSpPr/>
+          <p:nvPr/>
+        </p:nvSpPr>
+        <p:spPr>
+          <a:xfrm>
+            <a:off x="6217920" y="1828800"/>
+            <a:ext cx="5486400" cy="3840480"/>
+          </a:xfrm>
+          <a:prstGeom prst="roundRect">
+            <a:avLst/>
+          </a:prstGeom>
+          <a:solidFill>
+            <a:srgbClr val="F6F8FA"/>
+          </a:solidFill>
+          <a:ln>
+            <a:noFill/>
+          </a:ln>
+        </p:spPr>
+        <p:style>
+          <a:lnRef idx="1">
+            <a:schemeClr val="accent1"/>
+          </a:lnRef>
+          <a:fillRef idx="3">
+            <a:schemeClr val="accent1"/>
+          </a:fillRef>
+          <a:effectRef idx="2">
+            <a:schemeClr val="accent1"/>
+          </a:effectRef>
+          <a:fontRef idx="minor">
+            <a:schemeClr val="lt1"/>
+          </a:fontRef>
+        </p:style>
+        <p:txBody>
+          <a:bodyPr rtlCol="0" anchor="ctr"/>
+          <a:lstStyle/>
+          <a:p>
+            <a:pPr algn="ctr"/>
+          </a:p>
+        </p:txBody>
+      </p:sp>
+      <p:sp>
+        <p:nvSpPr>
+          <p:cNvPr id="14" name="Rectangle 13"/>
+          <p:cNvSpPr/>
+          <p:nvPr/>
+        </p:nvSpPr>
+        <p:spPr>
+          <a:xfrm>
+            <a:off x="6217920" y="1828800"/>
+            <a:ext cx="5486400" cy="54864"/>
+          </a:xfrm>
+          <a:prstGeom prst="rect">
+            <a:avLst/>
+          </a:prstGeom>
+          <a:solidFill>
+            <a:srgbClr val="006E82"/>
+          </a:solidFill>
+          <a:ln>
+            <a:noFill/>
+          </a:ln>
+        </p:spPr>
+        <p:style>
+          <a:lnRef idx="1">
+            <a:schemeClr val="accent1"/>
+          </a:lnRef>
+          <a:fillRef idx="3">
+            <a:schemeClr val="accent1"/>
+          </a:fillRef>
+          <a:effectRef idx="2">
+            <a:schemeClr val="accent1"/>
+          </a:effectRef>
+          <a:fontRef idx="minor">
+            <a:schemeClr val="lt1"/>
+          </a:fontRef>
+        </p:style>
+        <p:txBody>
+          <a:bodyPr rtlCol="0" anchor="ctr"/>
+          <a:lstStyle/>
+          <a:p>
+            <a:pPr algn="ctr"/>
+          </a:p>
+        </p:txBody>
+      </p:sp>
+      <p:sp>
+        <p:nvSpPr>
+          <p:cNvPr id="15" name="TextBox 14"/>
+          <p:cNvSpPr txBox="1"/>
+          <p:nvPr/>
+        </p:nvSpPr>
+        <p:spPr>
+          <a:xfrm>
+            <a:off x="6400800" y="2011680"/>
+            <a:ext cx="5120640" cy="320040"/>
+          </a:xfrm>
+          <a:prstGeom prst="rect">
+            <a:avLst/>
+          </a:prstGeom>
+          <a:noFill/>
+        </p:spPr>
+        <p:txBody>
+          <a:bodyPr wrap="square">
+            <a:spAutoFit/>
+          </a:bodyPr>
+          <a:lstStyle/>
+          <a:p>
             <a:pPr algn="l">
-              <a:defRPr sz="1200" b="0">
-                <a:solidFill>
-                  <a:srgbClr val="5F6E78"/>
-                </a:solidFill>
-                <a:latin typeface="Calibri"/>
-              </a:defRPr>
-            </a:pPr>
-            <a:r>
-              <a:t>Tip: edit these placeholders in PowerPoint before emailing Jean.</a:t>
+              <a:defRPr sz="1600" b="1">
+                <a:solidFill>
+                  <a:srgbClr val="0F1E2D"/>
+                </a:solidFill>
+                <a:latin typeface="Calibri"/>
+              </a:defRPr>
+            </a:pPr>
+            <a:r>
+              <a:t>Fly456 Business</a:t>
+            </a:r>
+          </a:p>
+        </p:txBody>
+      </p:sp>
+      <p:sp>
+        <p:nvSpPr>
+          <p:cNvPr id="16" name="TextBox 15"/>
+          <p:cNvSpPr txBox="1"/>
+          <p:nvPr/>
+        </p:nvSpPr>
+        <p:spPr>
+          <a:xfrm>
+            <a:off x="6400800" y="2377440"/>
+            <a:ext cx="5120640" cy="3108960"/>
+          </a:xfrm>
+          <a:prstGeom prst="rect">
+            <a:avLst/>
+          </a:prstGeom>
+          <a:noFill/>
+        </p:spPr>
+        <p:txBody>
+          <a:bodyPr wrap="square">
+            <a:spAutoFit/>
+          </a:bodyPr>
+          <a:lstStyle/>
+          <a:p>
+            <a:pPr>
+              <a:spcAft>
+                <a:spcPts val="400"/>
+              </a:spcAft>
+              <a:defRPr sz="1300">
+                <a:solidFill>
+                  <a:srgbClr val="19232D"/>
+                </a:solidFill>
+                <a:latin typeface="Calibri"/>
+              </a:defRPr>
+            </a:pPr>
+            <a:r>
+              <a:t>Monitors business-cabin opportunities</a:t>
+            </a:r>
+          </a:p>
+          <a:p>
+            <a:pPr>
+              <a:spcAft>
+                <a:spcPts val="400"/>
+              </a:spcAft>
+              <a:defRPr sz="1300">
+                <a:solidFill>
+                  <a:srgbClr val="19232D"/>
+                </a:solidFill>
+                <a:latin typeface="Calibri"/>
+              </a:defRPr>
+            </a:pPr>
+            <a:r>
+              <a:t>Same named criteria, business fares</a:t>
+            </a:r>
+          </a:p>
+          <a:p>
+            <a:pPr>
+              <a:spcAft>
+                <a:spcPts val="400"/>
+              </a:spcAft>
+              <a:defRPr sz="1300">
+                <a:solidFill>
+                  <a:srgbClr val="19232D"/>
+                </a:solidFill>
+                <a:latin typeface="Calibri"/>
+              </a:defRPr>
+            </a:pPr>
+            <a:r>
+              <a:t>Telegram notification to book fast</a:t>
+            </a:r>
+          </a:p>
+          <a:p>
+            <a:pPr>
+              <a:spcAft>
+                <a:spcPts val="400"/>
+              </a:spcAft>
+              <a:defRPr sz="1300">
+                <a:solidFill>
+                  <a:srgbClr val="19232D"/>
+                </a:solidFill>
+                <a:latin typeface="Calibri"/>
+              </a:defRPr>
+            </a:pPr>
+            <a:r>
+              <a:t>For travelers who want premium cabin</a:t>
+            </a:r>
+          </a:p>
+          <a:p>
+            <a:pPr>
+              <a:spcAft>
+                <a:spcPts val="400"/>
+              </a:spcAft>
+              <a:defRPr sz="1300">
+                <a:solidFill>
+                  <a:srgbClr val="19232D"/>
+                </a:solidFill>
+                <a:latin typeface="Calibri"/>
+              </a:defRPr>
+            </a:pPr>
+            <a:r>
+              <a:t>when the price finally drops into range</a:t>
             </a:r>
           </a:p>
         </p:txBody>
@@ -5402,7 +5849,7 @@
               </a:defRPr>
             </a:pPr>
             <a:r>
-              <a:t>MODEL &amp; ASK</a:t>
+              <a:t>TRACTION &amp; MODEL</a:t>
             </a:r>
           </a:p>
         </p:txBody>
@@ -5438,7 +5885,7 @@
               </a:defRPr>
             </a:pPr>
             <a:r>
-              <a:t>Subscription now. Affiliate / data later.</a:t>
+              <a:t>Replace brackets with live numbers before sending</a:t>
             </a:r>
           </a:p>
         </p:txBody>
@@ -5451,7 +5898,7 @@
         </p:nvSpPr>
         <p:spPr>
           <a:xfrm>
-            <a:off x="457200" y="1920240"/>
+            <a:off x="457200" y="1828800"/>
             <a:ext cx="5486400" cy="3840480"/>
           </a:xfrm>
           <a:prstGeom prst="roundRect">
@@ -5494,7 +5941,7 @@
         </p:nvSpPr>
         <p:spPr>
           <a:xfrm>
-            <a:off x="457200" y="1920240"/>
+            <a:off x="457200" y="1828800"/>
             <a:ext cx="5486400" cy="54864"/>
           </a:xfrm>
           <a:prstGeom prst="rect">
@@ -5537,7 +5984,7 @@
         </p:nvSpPr>
         <p:spPr>
           <a:xfrm>
-            <a:off x="640080" y="2103120"/>
+            <a:off x="640080" y="2011680"/>
             <a:ext cx="5120640" cy="320040"/>
           </a:xfrm>
           <a:prstGeom prst="rect">
@@ -5560,7 +6007,7 @@
               </a:defRPr>
             </a:pPr>
             <a:r>
-              <a:t>Business model</a:t>
+              <a:t>Traction</a:t>
             </a:r>
           </a:p>
         </p:txBody>
@@ -5573,7 +6020,7 @@
         </p:nvSpPr>
         <p:spPr>
           <a:xfrm>
-            <a:off x="640080" y="2468880"/>
+            <a:off x="640080" y="2377440"/>
             <a:ext cx="5120640" cy="3108960"/>
           </a:xfrm>
           <a:prstGeom prst="rect">
@@ -5599,7 +6046,7 @@
               </a:defRPr>
             </a:pPr>
             <a:r>
-              <a:t>Now: Premium route alerts (SaaS-lite)</a:t>
+              <a:t>Product live: fly456.com + @fly456bot</a:t>
             </a:r>
           </a:p>
           <a:p>
@@ -5615,7 +6062,7 @@
               </a:defRPr>
             </a:pPr>
             <a:r>
-              <a:t>Next: affiliate / partner take-rate</a:t>
+              <a:t>[N] active route alerts monitored</a:t>
             </a:r>
           </a:p>
           <a:p>
@@ -5631,7 +6078,7 @@
               </a:defRPr>
             </a:pPr>
             <a:r>
-              <a:t>Later: demand signals for OTAs</a:t>
+              <a:t>[P] paying subscribers · €[A] MRR</a:t>
             </a:r>
           </a:p>
           <a:p>
@@ -5647,7 +6094,7 @@
               </a:defRPr>
             </a:pPr>
             <a:r>
-              <a:t>GTM: organic Telegram + SEO routes</a:t>
+              <a:t>Stripe checkout inside Telegram</a:t>
             </a:r>
           </a:p>
           <a:p>
@@ -5663,7 +6110,7 @@
               </a:defRPr>
             </a:pPr>
             <a:r>
-              <a:t>Cost base: detection + messaging infra</a:t>
+              <a:t>Edit placeholders before send</a:t>
             </a:r>
           </a:p>
         </p:txBody>
@@ -5676,7 +6123,7 @@
         </p:nvSpPr>
         <p:spPr>
           <a:xfrm>
-            <a:off x="6217920" y="1920240"/>
+            <a:off x="6217920" y="1828800"/>
             <a:ext cx="5486400" cy="3840480"/>
           </a:xfrm>
           <a:prstGeom prst="roundRect">
@@ -5719,7 +6166,7 @@
         </p:nvSpPr>
         <p:spPr>
           <a:xfrm>
-            <a:off x="6217920" y="1920240"/>
+            <a:off x="6217920" y="1828800"/>
             <a:ext cx="5486400" cy="54864"/>
           </a:xfrm>
           <a:prstGeom prst="rect">
@@ -5762,7 +6209,7 @@
         </p:nvSpPr>
         <p:spPr>
           <a:xfrm>
-            <a:off x="6400800" y="2103120"/>
+            <a:off x="6400800" y="2011680"/>
             <a:ext cx="5120640" cy="320040"/>
           </a:xfrm>
           <a:prstGeom prst="rect">
@@ -5785,7 +6232,7 @@
               </a:defRPr>
             </a:pPr>
             <a:r>
-              <a:t>The ask (~€150k)</a:t>
+              <a:t>Model &amp; ask (~€150k)</a:t>
             </a:r>
           </a:p>
         </p:txBody>
@@ -5798,7 +6245,7 @@
         </p:nvSpPr>
         <p:spPr>
           <a:xfrm>
-            <a:off x="6400800" y="2468880"/>
+            <a:off x="6400800" y="2377440"/>
             <a:ext cx="5120640" cy="3108960"/>
           </a:xfrm>
           <a:prstGeom prst="rect">
@@ -5824,7 +6271,7 @@
               </a:defRPr>
             </a:pPr>
             <a:r>
-              <a:t>Scale high-intent LatAm corridors</a:t>
+              <a:t>Subscription for named route alerts</a:t>
             </a:r>
           </a:p>
           <a:p>
@@ -5840,7 +6287,7 @@
               </a:defRPr>
             </a:pPr>
             <a:r>
-              <a:t>Sharper detection + faster alerts</a:t>
+              <a:t>Economy + Business cabin products</a:t>
             </a:r>
           </a:p>
           <a:p>
@@ -5856,7 +6303,7 @@
               </a:defRPr>
             </a:pPr>
             <a:r>
-              <a:t>Conversion free → Premium</a:t>
+              <a:t>Later: affiliate / partner take-rate</a:t>
             </a:r>
           </a:p>
           <a:p>
@@ -5872,7 +6319,7 @@
               </a:defRPr>
             </a:pPr>
             <a:r>
-              <a:t>Pilot affiliate monetization</a:t>
+              <a:t>Use of funds: better monitoring,</a:t>
             </a:r>
           </a:p>
           <a:p>
@@ -5888,7 +6335,7 @@
               </a:defRPr>
             </a:pPr>
             <a:r>
-              <a:t>Keep burn low; prove LTV/CAC</a:t>
+              <a:t>faster alerts, convert &amp; retain users</a:t>
             </a:r>
           </a:p>
         </p:txBody>
@@ -6179,7 +6626,7 @@
               </a:defRPr>
             </a:pPr>
             <a:r>
-              <a:t>Operator-builder with AdTech &amp; product DNA</a:t>
+              <a:t>Operator-builder shipping the full loop</a:t>
             </a:r>
           </a:p>
         </p:txBody>
@@ -6218,7 +6665,7 @@
               </a:defRPr>
             </a:pPr>
             <a:r>
-              <a:t>•  Emiliano Tichauer — Founder (Spain; LatAm roots)</a:t>
+              <a:t>•  Emiliano Tichauer — Founder</a:t>
             </a:r>
           </a:p>
           <a:p>
@@ -6234,7 +6681,7 @@
               </a:defRPr>
             </a:pPr>
             <a:r>
-              <a:t>•  Built Parvus Media since 2013 (AdTech, data, performance; Madrid + Dubai footprint)</a:t>
+              <a:t>•  Built Parvus Media since 2013 (AdTech, data, performance products)</a:t>
             </a:r>
           </a:p>
           <a:p>
@@ -6250,7 +6697,7 @@
               </a:defRPr>
             </a:pPr>
             <a:r>
-              <a:t>•  Ships products end-to-end: detection, Telegram UX, Stripe billing</a:t>
+              <a:t>•  Owns the loop end-to-end: flight monitoring, Telegram UX, Stripe billing</a:t>
             </a:r>
           </a:p>
           <a:p>

</xml_diff>

<commit_message>
Update Fly456 traction slide with July 2026 launch metrics.
Include channel count, early Premium, Economy/Business pricing,
and keep the ~€150k ask on the same slide.

Co-authored-by: Emiliano Tichauer <Parvusmedia@users.noreply.github.com>
</commit_message>
<xml_diff>
--- a/Fly456_Kima_OnePager.pptx
+++ b/Fly456_Kima_OnePager.pptx
@@ -5849,7 +5849,7 @@
               </a:defRPr>
             </a:pPr>
             <a:r>
-              <a:t>TRACTION &amp; MODEL</a:t>
+              <a:t>TRACTION</a:t>
             </a:r>
           </a:p>
         </p:txBody>
@@ -5885,21 +5885,108 @@
               </a:defRPr>
             </a:pPr>
             <a:r>
-              <a:t>Replace brackets with live numbers before sending</a:t>
-            </a:r>
-          </a:p>
-        </p:txBody>
-      </p:sp>
-      <p:sp>
-        <p:nvSpPr>
-          <p:cNvPr id="9" name="Rounded Rectangle 8"/>
+              <a:t>Just launched July 2026, no marketing budget</a:t>
+            </a:r>
+          </a:p>
+        </p:txBody>
+      </p:sp>
+      <p:sp>
+        <p:nvSpPr>
+          <p:cNvPr id="9" name="TextBox 8"/>
+          <p:cNvSpPr txBox="1"/>
+          <p:nvPr/>
+        </p:nvSpPr>
+        <p:spPr>
+          <a:xfrm>
+            <a:off x="548640" y="1828800"/>
+            <a:ext cx="10972800" cy="3474720"/>
+          </a:xfrm>
+          <a:prstGeom prst="rect">
+            <a:avLst/>
+          </a:prstGeom>
+          <a:noFill/>
+        </p:spPr>
+        <p:txBody>
+          <a:bodyPr wrap="square">
+            <a:spAutoFit/>
+          </a:bodyPr>
+          <a:lstStyle/>
+          <a:p>
+            <a:pPr>
+              <a:spcAft>
+                <a:spcPts val="1000"/>
+              </a:spcAft>
+              <a:defRPr sz="1700">
+                <a:solidFill>
+                  <a:srgbClr val="19232D"/>
+                </a:solidFill>
+                <a:latin typeface="Calibri"/>
+              </a:defRPr>
+            </a:pPr>
+            <a:r>
+              <a:t>•  Currently 6 free channels live on Telegram for niche audiences (LatAm expats living in EU and US).</a:t>
+            </a:r>
+          </a:p>
+          <a:p>
+            <a:pPr>
+              <a:spcAft>
+                <a:spcPts val="1000"/>
+              </a:spcAft>
+              <a:defRPr sz="1700">
+                <a:solidFill>
+                  <a:srgbClr val="19232D"/>
+                </a:solidFill>
+                <a:latin typeface="Calibri"/>
+              </a:defRPr>
+            </a:pPr>
+            <a:r>
+              <a:t>•  Currently few paying Premium subscribers.</a:t>
+            </a:r>
+          </a:p>
+          <a:p>
+            <a:pPr>
+              <a:spcAft>
+                <a:spcPts val="1000"/>
+              </a:spcAft>
+              <a:defRPr sz="1700">
+                <a:solidFill>
+                  <a:srgbClr val="19232D"/>
+                </a:solidFill>
+                <a:latin typeface="Calibri"/>
+              </a:defRPr>
+            </a:pPr>
+            <a:r>
+              <a:t>•  Plans: Economy 5€/month | 20€/year · Business 12€/month | 99€/year. Stripe checkout in Telegram.</a:t>
+            </a:r>
+          </a:p>
+          <a:p>
+            <a:pPr>
+              <a:spcAft>
+                <a:spcPts val="1000"/>
+              </a:spcAft>
+              <a:defRPr sz="1700">
+                <a:solidFill>
+                  <a:srgbClr val="19232D"/>
+                </a:solidFill>
+                <a:latin typeface="Calibri"/>
+              </a:defRPr>
+            </a:pPr>
+            <a:r>
+              <a:t>•  Product live: fly456.com + @fly456bot</a:t>
+            </a:r>
+          </a:p>
+        </p:txBody>
+      </p:sp>
+      <p:sp>
+        <p:nvSpPr>
+          <p:cNvPr id="10" name="Rounded Rectangle 9"/>
           <p:cNvSpPr/>
           <p:nvPr/>
         </p:nvSpPr>
         <p:spPr>
           <a:xfrm>
-            <a:off x="457200" y="1828800"/>
-            <a:ext cx="5486400" cy="3840480"/>
+            <a:off x="457200" y="5029200"/>
+            <a:ext cx="11247120" cy="1371600"/>
           </a:xfrm>
           <a:prstGeom prst="roundRect">
             <a:avLst/>
@@ -5935,14 +6022,14 @@
       </p:sp>
       <p:sp>
         <p:nvSpPr>
-          <p:cNvPr id="10" name="Rectangle 9"/>
+          <p:cNvPr id="11" name="Rectangle 10"/>
           <p:cNvSpPr/>
           <p:nvPr/>
         </p:nvSpPr>
         <p:spPr>
           <a:xfrm>
-            <a:off x="457200" y="1828800"/>
-            <a:ext cx="5486400" cy="54864"/>
+            <a:off x="457200" y="5029200"/>
+            <a:ext cx="11247120" cy="54864"/>
           </a:xfrm>
           <a:prstGeom prst="rect">
             <a:avLst/>
@@ -5978,14 +6065,14 @@
       </p:sp>
       <p:sp>
         <p:nvSpPr>
-          <p:cNvPr id="11" name="TextBox 10"/>
+          <p:cNvPr id="12" name="TextBox 11"/>
           <p:cNvSpPr txBox="1"/>
           <p:nvPr/>
         </p:nvSpPr>
         <p:spPr>
           <a:xfrm>
-            <a:off x="640080" y="2011680"/>
-            <a:ext cx="5120640" cy="320040"/>
+            <a:off x="640080" y="5212080"/>
+            <a:ext cx="10881360" cy="320040"/>
           </a:xfrm>
           <a:prstGeom prst="rect">
             <a:avLst/>
@@ -6007,21 +6094,21 @@
               </a:defRPr>
             </a:pPr>
             <a:r>
-              <a:t>Traction</a:t>
-            </a:r>
-          </a:p>
-        </p:txBody>
-      </p:sp>
-      <p:sp>
-        <p:nvSpPr>
-          <p:cNvPr id="12" name="TextBox 11"/>
+              <a:t>The ask (~€150k)</a:t>
+            </a:r>
+          </a:p>
+        </p:txBody>
+      </p:sp>
+      <p:sp>
+        <p:nvSpPr>
+          <p:cNvPr id="13" name="TextBox 12"/>
           <p:cNvSpPr txBox="1"/>
           <p:nvPr/>
         </p:nvSpPr>
         <p:spPr>
           <a:xfrm>
-            <a:off x="640080" y="2377440"/>
-            <a:ext cx="5120640" cy="3108960"/>
+            <a:off x="640080" y="5577840"/>
+            <a:ext cx="10881360" cy="640080"/>
           </a:xfrm>
           <a:prstGeom prst="rect">
             <a:avLst/>
@@ -6046,296 +6133,7 @@
               </a:defRPr>
             </a:pPr>
             <a:r>
-              <a:t>Product live: fly456.com + @fly456bot</a:t>
-            </a:r>
-          </a:p>
-          <a:p>
-            <a:pPr>
-              <a:spcAft>
-                <a:spcPts val="400"/>
-              </a:spcAft>
-              <a:defRPr sz="1300">
-                <a:solidFill>
-                  <a:srgbClr val="19232D"/>
-                </a:solidFill>
-                <a:latin typeface="Calibri"/>
-              </a:defRPr>
-            </a:pPr>
-            <a:r>
-              <a:t>[N] active route alerts monitored</a:t>
-            </a:r>
-          </a:p>
-          <a:p>
-            <a:pPr>
-              <a:spcAft>
-                <a:spcPts val="400"/>
-              </a:spcAft>
-              <a:defRPr sz="1300">
-                <a:solidFill>
-                  <a:srgbClr val="19232D"/>
-                </a:solidFill>
-                <a:latin typeface="Calibri"/>
-              </a:defRPr>
-            </a:pPr>
-            <a:r>
-              <a:t>[P] paying subscribers · €[A] MRR</a:t>
-            </a:r>
-          </a:p>
-          <a:p>
-            <a:pPr>
-              <a:spcAft>
-                <a:spcPts val="400"/>
-              </a:spcAft>
-              <a:defRPr sz="1300">
-                <a:solidFill>
-                  <a:srgbClr val="19232D"/>
-                </a:solidFill>
-                <a:latin typeface="Calibri"/>
-              </a:defRPr>
-            </a:pPr>
-            <a:r>
-              <a:t>Stripe checkout inside Telegram</a:t>
-            </a:r>
-          </a:p>
-          <a:p>
-            <a:pPr>
-              <a:spcAft>
-                <a:spcPts val="400"/>
-              </a:spcAft>
-              <a:defRPr sz="1300">
-                <a:solidFill>
-                  <a:srgbClr val="19232D"/>
-                </a:solidFill>
-                <a:latin typeface="Calibri"/>
-              </a:defRPr>
-            </a:pPr>
-            <a:r>
-              <a:t>Edit placeholders before send</a:t>
-            </a:r>
-          </a:p>
-        </p:txBody>
-      </p:sp>
-      <p:sp>
-        <p:nvSpPr>
-          <p:cNvPr id="13" name="Rounded Rectangle 12"/>
-          <p:cNvSpPr/>
-          <p:nvPr/>
-        </p:nvSpPr>
-        <p:spPr>
-          <a:xfrm>
-            <a:off x="6217920" y="1828800"/>
-            <a:ext cx="5486400" cy="3840480"/>
-          </a:xfrm>
-          <a:prstGeom prst="roundRect">
-            <a:avLst/>
-          </a:prstGeom>
-          <a:solidFill>
-            <a:srgbClr val="F6F8FA"/>
-          </a:solidFill>
-          <a:ln>
-            <a:noFill/>
-          </a:ln>
-        </p:spPr>
-        <p:style>
-          <a:lnRef idx="1">
-            <a:schemeClr val="accent1"/>
-          </a:lnRef>
-          <a:fillRef idx="3">
-            <a:schemeClr val="accent1"/>
-          </a:fillRef>
-          <a:effectRef idx="2">
-            <a:schemeClr val="accent1"/>
-          </a:effectRef>
-          <a:fontRef idx="minor">
-            <a:schemeClr val="lt1"/>
-          </a:fontRef>
-        </p:style>
-        <p:txBody>
-          <a:bodyPr rtlCol="0" anchor="ctr"/>
-          <a:lstStyle/>
-          <a:p>
-            <a:pPr algn="ctr"/>
-          </a:p>
-        </p:txBody>
-      </p:sp>
-      <p:sp>
-        <p:nvSpPr>
-          <p:cNvPr id="14" name="Rectangle 13"/>
-          <p:cNvSpPr/>
-          <p:nvPr/>
-        </p:nvSpPr>
-        <p:spPr>
-          <a:xfrm>
-            <a:off x="6217920" y="1828800"/>
-            <a:ext cx="5486400" cy="54864"/>
-          </a:xfrm>
-          <a:prstGeom prst="rect">
-            <a:avLst/>
-          </a:prstGeom>
-          <a:solidFill>
-            <a:srgbClr val="006E82"/>
-          </a:solidFill>
-          <a:ln>
-            <a:noFill/>
-          </a:ln>
-        </p:spPr>
-        <p:style>
-          <a:lnRef idx="1">
-            <a:schemeClr val="accent1"/>
-          </a:lnRef>
-          <a:fillRef idx="3">
-            <a:schemeClr val="accent1"/>
-          </a:fillRef>
-          <a:effectRef idx="2">
-            <a:schemeClr val="accent1"/>
-          </a:effectRef>
-          <a:fontRef idx="minor">
-            <a:schemeClr val="lt1"/>
-          </a:fontRef>
-        </p:style>
-        <p:txBody>
-          <a:bodyPr rtlCol="0" anchor="ctr"/>
-          <a:lstStyle/>
-          <a:p>
-            <a:pPr algn="ctr"/>
-          </a:p>
-        </p:txBody>
-      </p:sp>
-      <p:sp>
-        <p:nvSpPr>
-          <p:cNvPr id="15" name="TextBox 14"/>
-          <p:cNvSpPr txBox="1"/>
-          <p:nvPr/>
-        </p:nvSpPr>
-        <p:spPr>
-          <a:xfrm>
-            <a:off x="6400800" y="2011680"/>
-            <a:ext cx="5120640" cy="320040"/>
-          </a:xfrm>
-          <a:prstGeom prst="rect">
-            <a:avLst/>
-          </a:prstGeom>
-          <a:noFill/>
-        </p:spPr>
-        <p:txBody>
-          <a:bodyPr wrap="square">
-            <a:spAutoFit/>
-          </a:bodyPr>
-          <a:lstStyle/>
-          <a:p>
-            <a:pPr algn="l">
-              <a:defRPr sz="1600" b="1">
-                <a:solidFill>
-                  <a:srgbClr val="0F1E2D"/>
-                </a:solidFill>
-                <a:latin typeface="Calibri"/>
-              </a:defRPr>
-            </a:pPr>
-            <a:r>
-              <a:t>Model &amp; ask (~€150k)</a:t>
-            </a:r>
-          </a:p>
-        </p:txBody>
-      </p:sp>
-      <p:sp>
-        <p:nvSpPr>
-          <p:cNvPr id="16" name="TextBox 15"/>
-          <p:cNvSpPr txBox="1"/>
-          <p:nvPr/>
-        </p:nvSpPr>
-        <p:spPr>
-          <a:xfrm>
-            <a:off x="6400800" y="2377440"/>
-            <a:ext cx="5120640" cy="3108960"/>
-          </a:xfrm>
-          <a:prstGeom prst="rect">
-            <a:avLst/>
-          </a:prstGeom>
-          <a:noFill/>
-        </p:spPr>
-        <p:txBody>
-          <a:bodyPr wrap="square">
-            <a:spAutoFit/>
-          </a:bodyPr>
-          <a:lstStyle/>
-          <a:p>
-            <a:pPr>
-              <a:spcAft>
-                <a:spcPts val="400"/>
-              </a:spcAft>
-              <a:defRPr sz="1300">
-                <a:solidFill>
-                  <a:srgbClr val="19232D"/>
-                </a:solidFill>
-                <a:latin typeface="Calibri"/>
-              </a:defRPr>
-            </a:pPr>
-            <a:r>
-              <a:t>Subscription for named route alerts</a:t>
-            </a:r>
-          </a:p>
-          <a:p>
-            <a:pPr>
-              <a:spcAft>
-                <a:spcPts val="400"/>
-              </a:spcAft>
-              <a:defRPr sz="1300">
-                <a:solidFill>
-                  <a:srgbClr val="19232D"/>
-                </a:solidFill>
-                <a:latin typeface="Calibri"/>
-              </a:defRPr>
-            </a:pPr>
-            <a:r>
-              <a:t>Economy + Business cabin products</a:t>
-            </a:r>
-          </a:p>
-          <a:p>
-            <a:pPr>
-              <a:spcAft>
-                <a:spcPts val="400"/>
-              </a:spcAft>
-              <a:defRPr sz="1300">
-                <a:solidFill>
-                  <a:srgbClr val="19232D"/>
-                </a:solidFill>
-                <a:latin typeface="Calibri"/>
-              </a:defRPr>
-            </a:pPr>
-            <a:r>
-              <a:t>Later: affiliate / partner take-rate</a:t>
-            </a:r>
-          </a:p>
-          <a:p>
-            <a:pPr>
-              <a:spcAft>
-                <a:spcPts val="400"/>
-              </a:spcAft>
-              <a:defRPr sz="1300">
-                <a:solidFill>
-                  <a:srgbClr val="19232D"/>
-                </a:solidFill>
-                <a:latin typeface="Calibri"/>
-              </a:defRPr>
-            </a:pPr>
-            <a:r>
-              <a:t>Use of funds: better monitoring,</a:t>
-            </a:r>
-          </a:p>
-          <a:p>
-            <a:pPr>
-              <a:spcAft>
-                <a:spcPts val="400"/>
-              </a:spcAft>
-              <a:defRPr sz="1300">
-                <a:solidFill>
-                  <a:srgbClr val="19232D"/>
-                </a:solidFill>
-                <a:latin typeface="Calibri"/>
-              </a:defRPr>
-            </a:pPr>
-            <a:r>
-              <a:t>faster alerts, convert &amp; retain users</a:t>
+              <a:t>Sharper monitoring · faster Telegram alerts · grow paid Economy + Business · keep burn low</a:t>
             </a:r>
           </a:p>
         </p:txBody>

</xml_diff>

<commit_message>
Compress Fly456 Kima pitch to a true 1-slide one-pager.
Single editable PPTX with problem, product, Economy/Business,
traction and ask for cold email outreach.

Co-authored-by: Emiliano Tichauer <Parvusmedia@users.noreply.github.com>
</commit_message>
<xml_diff>
--- a/Fly456_Kima_OnePager.pptx
+++ b/Fly456_Kima_OnePager.pptx
@@ -6,11 +6,6 @@
   </p:sldMasterIdLst>
   <p:sldIdLst>
     <p:sldId id="256" r:id="rId7"/>
-    <p:sldId id="257" r:id="rId8"/>
-    <p:sldId id="258" r:id="rId9"/>
-    <p:sldId id="259" r:id="rId10"/>
-    <p:sldId id="260" r:id="rId11"/>
-    <p:sldId id="261" r:id="rId12"/>
   </p:sldIdLst>
   <p:sldSz cx="12191695" cy="6858000" type="screen4x3"/>
   <p:notesSz cx="6858000" cy="9144000"/>
@@ -3108,7 +3103,7 @@
             <a:avLst/>
           </a:prstGeom>
           <a:solidFill>
-            <a:srgbClr val="0F1E2D"/>
+            <a:srgbClr val="FFFFFF"/>
           </a:solidFill>
           <a:ln>
             <a:noFill/>
@@ -3145,7 +3140,7 @@
         <p:spPr>
           <a:xfrm>
             <a:off x="0" y="0"/>
-            <a:ext cx="256032" cy="6858000"/>
+            <a:ext cx="164592" cy="6858000"/>
           </a:xfrm>
           <a:prstGeom prst="rect">
             <a:avLst/>
@@ -3187,14 +3182,14 @@
         </p:nvSpPr>
         <p:spPr>
           <a:xfrm>
-            <a:off x="256032" y="5989320"/>
-            <a:ext cx="11935663" cy="128016"/>
+            <a:off x="164592" y="0"/>
+            <a:ext cx="12027103" cy="1234440"/>
           </a:xfrm>
           <a:prstGeom prst="rect">
             <a:avLst/>
           </a:prstGeom>
           <a:solidFill>
-            <a:srgbClr val="E67828"/>
+            <a:srgbClr val="0F1E2D"/>
           </a:solidFill>
           <a:ln>
             <a:noFill/>
@@ -3224,294 +3219,20 @@
       </p:sp>
       <p:sp>
         <p:nvSpPr>
-          <p:cNvPr id="5" name="TextBox 4"/>
-          <p:cNvSpPr txBox="1"/>
-          <p:nvPr/>
-        </p:nvSpPr>
-        <p:spPr>
-          <a:xfrm>
-            <a:off x="640080" y="1097280"/>
-            <a:ext cx="10058400" cy="365760"/>
-          </a:xfrm>
-          <a:prstGeom prst="rect">
-            <a:avLst/>
-          </a:prstGeom>
-          <a:noFill/>
-        </p:spPr>
-        <p:txBody>
-          <a:bodyPr wrap="square">
-            <a:spAutoFit/>
-          </a:bodyPr>
-          <a:lstStyle/>
-          <a:p>
-            <a:pPr algn="l">
-              <a:defRPr sz="1400" b="0">
-                <a:solidFill>
-                  <a:srgbClr val="B4C8D2"/>
-                </a:solidFill>
-                <a:latin typeface="Calibri"/>
-              </a:defRPr>
-            </a:pPr>
-            <a:r>
-              <a:t>PRE-SEED  ·  FLIGHT MONITORING  ·  TELEGRAM ALERTS</a:t>
-            </a:r>
-          </a:p>
-        </p:txBody>
-      </p:sp>
-      <p:sp>
-        <p:nvSpPr>
-          <p:cNvPr id="6" name="TextBox 5"/>
-          <p:cNvSpPr txBox="1"/>
-          <p:nvPr/>
-        </p:nvSpPr>
-        <p:spPr>
-          <a:xfrm>
-            <a:off x="640080" y="1645920"/>
-            <a:ext cx="10058400" cy="822960"/>
-          </a:xfrm>
-          <a:prstGeom prst="rect">
-            <a:avLst/>
-          </a:prstGeom>
-          <a:noFill/>
-        </p:spPr>
-        <p:txBody>
-          <a:bodyPr wrap="square">
-            <a:spAutoFit/>
-          </a:bodyPr>
-          <a:lstStyle/>
-          <a:p>
-            <a:pPr algn="l">
-              <a:defRPr sz="5400" b="1">
-                <a:solidFill>
-                  <a:srgbClr val="FFFFFF"/>
-                </a:solidFill>
-                <a:latin typeface="Calibri"/>
-              </a:defRPr>
-            </a:pPr>
-            <a:r>
-              <a:t>Fly456</a:t>
-            </a:r>
-          </a:p>
-        </p:txBody>
-      </p:sp>
-      <p:sp>
-        <p:nvSpPr>
-          <p:cNvPr id="7" name="TextBox 6"/>
-          <p:cNvSpPr txBox="1"/>
-          <p:nvPr/>
-        </p:nvSpPr>
-        <p:spPr>
-          <a:xfrm>
-            <a:off x="640080" y="2560320"/>
-            <a:ext cx="10058400" cy="1097280"/>
-          </a:xfrm>
-          <a:prstGeom prst="rect">
-            <a:avLst/>
-          </a:prstGeom>
-          <a:noFill/>
-        </p:spPr>
-        <p:txBody>
-          <a:bodyPr wrap="square">
-            <a:spAutoFit/>
-          </a:bodyPr>
-          <a:lstStyle/>
-          <a:p>
-            <a:pPr algn="l">
-              <a:defRPr sz="2000" b="0">
-                <a:solidFill>
-                  <a:srgbClr val="C8DCE1"/>
-                </a:solidFill>
-                <a:latin typeface="Calibri"/>
-              </a:defRPr>
-            </a:pPr>
-            <a:r>
-              <a:t>You set origin, destination, dates and max price.</a:t>
-            </a:r>
-            <a:br/>
-            <a:r>
-              <a:t>We monitor flights and notify you on Telegram — so you can book fast.</a:t>
-            </a:r>
-          </a:p>
-        </p:txBody>
-      </p:sp>
-      <p:sp>
-        <p:nvSpPr>
-          <p:cNvPr id="8" name="TextBox 7"/>
-          <p:cNvSpPr txBox="1"/>
-          <p:nvPr/>
-        </p:nvSpPr>
-        <p:spPr>
-          <a:xfrm>
-            <a:off x="640080" y="3931920"/>
-            <a:ext cx="10058400" cy="365760"/>
-          </a:xfrm>
-          <a:prstGeom prst="rect">
-            <a:avLst/>
-          </a:prstGeom>
-          <a:noFill/>
-        </p:spPr>
-        <p:txBody>
-          <a:bodyPr wrap="square">
-            <a:spAutoFit/>
-          </a:bodyPr>
-          <a:lstStyle/>
-          <a:p>
-            <a:pPr algn="l">
-              <a:defRPr sz="1600" b="1">
-                <a:solidFill>
-                  <a:srgbClr val="E67828"/>
-                </a:solidFill>
-                <a:latin typeface="Calibri"/>
-              </a:defRPr>
-            </a:pPr>
-            <a:r>
-              <a:t>Two products: Economy cabin  ·  Business cabin</a:t>
-            </a:r>
-          </a:p>
-        </p:txBody>
-      </p:sp>
-      <p:sp>
-        <p:nvSpPr>
-          <p:cNvPr id="9" name="TextBox 8"/>
-          <p:cNvSpPr txBox="1"/>
-          <p:nvPr/>
-        </p:nvSpPr>
-        <p:spPr>
-          <a:xfrm>
-            <a:off x="640080" y="4572000"/>
-            <a:ext cx="10058400" cy="365760"/>
-          </a:xfrm>
-          <a:prstGeom prst="rect">
-            <a:avLst/>
-          </a:prstGeom>
-          <a:noFill/>
-        </p:spPr>
-        <p:txBody>
-          <a:bodyPr wrap="square">
-            <a:spAutoFit/>
-          </a:bodyPr>
-          <a:lstStyle/>
-          <a:p>
-            <a:pPr algn="l">
-              <a:defRPr sz="1500" b="1">
-                <a:solidFill>
-                  <a:srgbClr val="A0B4BE"/>
-                </a:solidFill>
-                <a:latin typeface="Calibri"/>
-              </a:defRPr>
-            </a:pPr>
-            <a:r>
-              <a:t>Asking: ~€150k pre-seed  ·  fly456.com  ·  @fly456bot</a:t>
-            </a:r>
-          </a:p>
-        </p:txBody>
-      </p:sp>
-      <p:sp>
-        <p:nvSpPr>
-          <p:cNvPr id="10" name="TextBox 9"/>
-          <p:cNvSpPr txBox="1"/>
-          <p:nvPr/>
-        </p:nvSpPr>
-        <p:spPr>
-          <a:xfrm>
-            <a:off x="640080" y="5120640"/>
-            <a:ext cx="10058400" cy="365760"/>
-          </a:xfrm>
-          <a:prstGeom prst="rect">
-            <a:avLst/>
-          </a:prstGeom>
-          <a:noFill/>
-        </p:spPr>
-        <p:txBody>
-          <a:bodyPr wrap="square">
-            <a:spAutoFit/>
-          </a:bodyPr>
-          <a:lstStyle/>
-          <a:p>
-            <a:pPr algn="l">
-              <a:defRPr sz="1400" b="0">
-                <a:solidFill>
-                  <a:srgbClr val="A0B4BE"/>
-                </a:solidFill>
-                <a:latin typeface="Calibri"/>
-              </a:defRPr>
-            </a:pPr>
-            <a:r>
-              <a:t>Emiliano Tichauer  ·  Founder</a:t>
-            </a:r>
-          </a:p>
-        </p:txBody>
-      </p:sp>
-      <p:sp>
-        <p:nvSpPr>
-          <p:cNvPr id="11" name="TextBox 10"/>
-          <p:cNvSpPr txBox="1"/>
-          <p:nvPr/>
-        </p:nvSpPr>
-        <p:spPr>
-          <a:xfrm>
-            <a:off x="640080" y="6263640"/>
-            <a:ext cx="1828800" cy="274320"/>
-          </a:xfrm>
-          <a:prstGeom prst="rect">
-            <a:avLst/>
-          </a:prstGeom>
-          <a:noFill/>
-        </p:spPr>
-        <p:txBody>
-          <a:bodyPr wrap="square">
-            <a:spAutoFit/>
-          </a:bodyPr>
-          <a:lstStyle/>
-          <a:p>
-            <a:pPr algn="l">
-              <a:defRPr sz="1200" b="0">
-                <a:solidFill>
-                  <a:srgbClr val="8CA0AA"/>
-                </a:solidFill>
-                <a:latin typeface="Calibri"/>
-              </a:defRPr>
-            </a:pPr>
-            <a:r>
-              <a:t>1/6</a:t>
-            </a:r>
-          </a:p>
-        </p:txBody>
-      </p:sp>
-    </p:spTree>
-  </p:cSld>
-  <p:clrMapOvr>
-    <a:masterClrMapping/>
-  </p:clrMapOvr>
-</p:sld>
-</file>
-
-<file path=ppt/slides/slide2.xml><?xml version="1.0" encoding="utf-8"?>
-<p:sld xmlns:a="http://schemas.openxmlformats.org/drawingml/2006/main" xmlns:p="http://schemas.openxmlformats.org/presentationml/2006/main" xmlns:r="http://schemas.openxmlformats.org/officeDocument/2006/relationships">
-  <p:cSld>
-    <p:spTree>
-      <p:nvGrpSpPr>
-        <p:cNvPr id="1" name=""/>
-        <p:cNvGrpSpPr/>
-        <p:nvPr/>
-      </p:nvGrpSpPr>
-      <p:grpSpPr/>
-      <p:sp>
-        <p:nvSpPr>
-          <p:cNvPr id="2" name="Rectangle 1"/>
+          <p:cNvPr id="5" name="Rectangle 4"/>
           <p:cNvSpPr/>
           <p:nvPr/>
         </p:nvSpPr>
         <p:spPr>
           <a:xfrm>
-            <a:off x="0" y="0"/>
-            <a:ext cx="12191695" cy="6858000"/>
+            <a:off x="164592" y="1234440"/>
+            <a:ext cx="12027103" cy="54864"/>
           </a:xfrm>
           <a:prstGeom prst="rect">
             <a:avLst/>
           </a:prstGeom>
           <a:solidFill>
-            <a:srgbClr val="FFFFFF"/>
+            <a:srgbClr val="E67828"/>
           </a:solidFill>
           <a:ln>
             <a:noFill/>
@@ -3541,20 +3262,192 @@
       </p:sp>
       <p:sp>
         <p:nvSpPr>
-          <p:cNvPr id="3" name="Rectangle 2"/>
-          <p:cNvSpPr/>
+          <p:cNvPr id="6" name="TextBox 5"/>
+          <p:cNvSpPr txBox="1"/>
           <p:nvPr/>
         </p:nvSpPr>
         <p:spPr>
           <a:xfrm>
-            <a:off x="0" y="0"/>
-            <a:ext cx="201168" cy="6858000"/>
+            <a:off x="411480" y="164592"/>
+            <a:ext cx="7315200" cy="274320"/>
           </a:xfrm>
           <a:prstGeom prst="rect">
             <a:avLst/>
           </a:prstGeom>
+          <a:noFill/>
+        </p:spPr>
+        <p:txBody>
+          <a:bodyPr wrap="square">
+            <a:spAutoFit/>
+          </a:bodyPr>
+          <a:lstStyle/>
+          <a:p>
+            <a:pPr algn="l">
+              <a:spcAft>
+                <a:spcPts val="200"/>
+              </a:spcAft>
+              <a:defRPr sz="1100" b="0">
+                <a:solidFill>
+                  <a:srgbClr val="B4C8D2"/>
+                </a:solidFill>
+                <a:latin typeface="Calibri"/>
+              </a:defRPr>
+            </a:pPr>
+            <a:r>
+              <a:t>FLY456  ·  ONE-PAGER FOR KIMA  ·  PRE-SEED</a:t>
+            </a:r>
+          </a:p>
+        </p:txBody>
+      </p:sp>
+      <p:sp>
+        <p:nvSpPr>
+          <p:cNvPr id="7" name="TextBox 6"/>
+          <p:cNvSpPr txBox="1"/>
+          <p:nvPr/>
+        </p:nvSpPr>
+        <p:spPr>
+          <a:xfrm>
+            <a:off x="411480" y="438912"/>
+            <a:ext cx="8229600" cy="411480"/>
+          </a:xfrm>
+          <a:prstGeom prst="rect">
+            <a:avLst/>
+          </a:prstGeom>
+          <a:noFill/>
+        </p:spPr>
+        <p:txBody>
+          <a:bodyPr wrap="square">
+            <a:spAutoFit/>
+          </a:bodyPr>
+          <a:lstStyle/>
+          <a:p>
+            <a:pPr algn="l">
+              <a:spcAft>
+                <a:spcPts val="200"/>
+              </a:spcAft>
+              <a:defRPr sz="2600" b="1">
+                <a:solidFill>
+                  <a:srgbClr val="FFFFFF"/>
+                </a:solidFill>
+                <a:latin typeface="Calibri"/>
+              </a:defRPr>
+            </a:pPr>
+            <a:r>
+              <a:t>Named flight monitoring. Telegram alert. Book fast.</a:t>
+            </a:r>
+          </a:p>
+        </p:txBody>
+      </p:sp>
+      <p:sp>
+        <p:nvSpPr>
+          <p:cNvPr id="8" name="TextBox 7"/>
+          <p:cNvSpPr txBox="1"/>
+          <p:nvPr/>
+        </p:nvSpPr>
+        <p:spPr>
+          <a:xfrm>
+            <a:off x="411480" y="868680"/>
+            <a:ext cx="9144000" cy="274320"/>
+          </a:xfrm>
+          <a:prstGeom prst="rect">
+            <a:avLst/>
+          </a:prstGeom>
+          <a:noFill/>
+        </p:spPr>
+        <p:txBody>
+          <a:bodyPr wrap="square">
+            <a:spAutoFit/>
+          </a:bodyPr>
+          <a:lstStyle/>
+          <a:p>
+            <a:pPr algn="l">
+              <a:spcAft>
+                <a:spcPts val="200"/>
+              </a:spcAft>
+              <a:defRPr sz="1400" b="0">
+                <a:solidFill>
+                  <a:srgbClr val="C8DCE1"/>
+                </a:solidFill>
+                <a:latin typeface="Calibri"/>
+              </a:defRPr>
+            </a:pPr>
+            <a:r>
+              <a:t>Origin · Destination · Dates · Max price  →  alert on @fly456bot</a:t>
+            </a:r>
+          </a:p>
+        </p:txBody>
+      </p:sp>
+      <p:sp>
+        <p:nvSpPr>
+          <p:cNvPr id="9" name="TextBox 8"/>
+          <p:cNvSpPr txBox="1"/>
+          <p:nvPr/>
+        </p:nvSpPr>
+        <p:spPr>
+          <a:xfrm>
+            <a:off x="9326880" y="320040"/>
+            <a:ext cx="2560320" cy="640080"/>
+          </a:xfrm>
+          <a:prstGeom prst="rect">
+            <a:avLst/>
+          </a:prstGeom>
+          <a:noFill/>
+        </p:spPr>
+        <p:txBody>
+          <a:bodyPr wrap="square">
+            <a:spAutoFit/>
+          </a:bodyPr>
+          <a:lstStyle/>
+          <a:p>
+            <a:pPr algn="r">
+              <a:spcAft>
+                <a:spcPts val="200"/>
+              </a:spcAft>
+              <a:defRPr sz="2000" b="1">
+                <a:solidFill>
+                  <a:srgbClr val="E67828"/>
+                </a:solidFill>
+                <a:latin typeface="Calibri"/>
+              </a:defRPr>
+            </a:pPr>
+            <a:r>
+              <a:t>Ask</a:t>
+            </a:r>
+          </a:p>
+          <a:p>
+            <a:pPr algn="r">
+              <a:spcAft>
+                <a:spcPts val="200"/>
+              </a:spcAft>
+              <a:defRPr sz="2000" b="1">
+                <a:solidFill>
+                  <a:srgbClr val="E67828"/>
+                </a:solidFill>
+                <a:latin typeface="Calibri"/>
+              </a:defRPr>
+            </a:pPr>
+            <a:r>
+              <a:t>~€150k</a:t>
+            </a:r>
+          </a:p>
+        </p:txBody>
+      </p:sp>
+      <p:sp>
+        <p:nvSpPr>
+          <p:cNvPr id="10" name="Rounded Rectangle 9"/>
+          <p:cNvSpPr/>
+          <p:nvPr/>
+        </p:nvSpPr>
+        <p:spPr>
+          <a:xfrm>
+            <a:off x="365760" y="1463040"/>
+            <a:ext cx="5669280" cy="1965960"/>
+          </a:xfrm>
+          <a:prstGeom prst="roundRect">
+            <a:avLst/>
+          </a:prstGeom>
           <a:solidFill>
-            <a:srgbClr val="006E82"/>
+            <a:srgbClr val="F6F8FA"/>
           </a:solidFill>
           <a:ln>
             <a:noFill/>
@@ -3584,20 +3477,20 @@
       </p:sp>
       <p:sp>
         <p:nvSpPr>
-          <p:cNvPr id="4" name="Rectangle 3"/>
+          <p:cNvPr id="11" name="Rectangle 10"/>
           <p:cNvSpPr/>
           <p:nvPr/>
         </p:nvSpPr>
         <p:spPr>
           <a:xfrm>
-            <a:off x="201168" y="0"/>
-            <a:ext cx="11990527" cy="411480"/>
+            <a:off x="365760" y="1463040"/>
+            <a:ext cx="5669280" cy="45720"/>
           </a:xfrm>
           <a:prstGeom prst="rect">
             <a:avLst/>
           </a:prstGeom>
           <a:solidFill>
-            <a:srgbClr val="F6F8FA"/>
+            <a:srgbClr val="006E82"/>
           </a:solidFill>
           <a:ln>
             <a:noFill/>
@@ -3627,14 +3520,14 @@
       </p:sp>
       <p:sp>
         <p:nvSpPr>
-          <p:cNvPr id="5" name="TextBox 4"/>
+          <p:cNvPr id="12" name="TextBox 11"/>
           <p:cNvSpPr txBox="1"/>
           <p:nvPr/>
         </p:nvSpPr>
         <p:spPr>
           <a:xfrm>
-            <a:off x="411480" y="73152"/>
-            <a:ext cx="9144000" cy="274320"/>
+            <a:off x="502920" y="1572768"/>
+            <a:ext cx="5394960" cy="256032"/>
           </a:xfrm>
           <a:prstGeom prst="rect">
             <a:avLst/>
@@ -3642,85 +3535,16 @@
           <a:noFill/>
         </p:spPr>
         <p:txBody>
-          <a:bodyPr wrap="none">
-            <a:spAutoFit/>
-          </a:bodyPr>
-          <a:lstStyle/>
-          <a:p>
-            <a:pPr>
-              <a:defRPr sz="1100">
-                <a:solidFill>
-                  <a:srgbClr val="5F6E78"/>
-                </a:solidFill>
-                <a:latin typeface="Calibri"/>
-              </a:defRPr>
-            </a:pPr>
-            <a:r>
-              <a:t>Fly456  ·  Pre-seed note for Kima Ventures</a:t>
-            </a:r>
-          </a:p>
-        </p:txBody>
-      </p:sp>
-      <p:sp>
-        <p:nvSpPr>
-          <p:cNvPr id="6" name="TextBox 5"/>
-          <p:cNvSpPr txBox="1"/>
-          <p:nvPr/>
-        </p:nvSpPr>
-        <p:spPr>
-          <a:xfrm>
-            <a:off x="11155680" y="73152"/>
-            <a:ext cx="822960" cy="274320"/>
-          </a:xfrm>
-          <a:prstGeom prst="rect">
-            <a:avLst/>
-          </a:prstGeom>
-          <a:noFill/>
-        </p:spPr>
-        <p:txBody>
           <a:bodyPr wrap="square">
             <a:spAutoFit/>
           </a:bodyPr>
           <a:lstStyle/>
           <a:p>
-            <a:pPr algn="r">
-              <a:defRPr sz="1100" b="0">
-                <a:solidFill>
-                  <a:srgbClr val="5F6E78"/>
-                </a:solidFill>
-                <a:latin typeface="Calibri"/>
-              </a:defRPr>
-            </a:pPr>
-            <a:r>
-              <a:t>2/6</a:t>
-            </a:r>
-          </a:p>
-        </p:txBody>
-      </p:sp>
-      <p:sp>
-        <p:nvSpPr>
-          <p:cNvPr id="7" name="TextBox 6"/>
-          <p:cNvSpPr txBox="1"/>
-          <p:nvPr/>
-        </p:nvSpPr>
-        <p:spPr>
-          <a:xfrm>
-            <a:off x="457200" y="640080"/>
-            <a:ext cx="10972800" cy="274320"/>
-          </a:xfrm>
-          <a:prstGeom prst="rect">
-            <a:avLst/>
-          </a:prstGeom>
-          <a:noFill/>
-        </p:spPr>
-        <p:txBody>
-          <a:bodyPr wrap="square">
-            <a:spAutoFit/>
-          </a:bodyPr>
-          <a:lstStyle/>
-          <a:p>
             <a:pPr algn="l">
-              <a:defRPr sz="1200" b="1">
+              <a:spcAft>
+                <a:spcPts val="200"/>
+              </a:spcAft>
+              <a:defRPr sz="1300" b="1">
                 <a:solidFill>
                   <a:srgbClr val="006E82"/>
                 </a:solidFill>
@@ -3735,14 +3559,14 @@
       </p:sp>
       <p:sp>
         <p:nvSpPr>
-          <p:cNvPr id="8" name="TextBox 7"/>
+          <p:cNvPr id="13" name="TextBox 12"/>
           <p:cNvSpPr txBox="1"/>
           <p:nvPr/>
         </p:nvSpPr>
         <p:spPr>
           <a:xfrm>
-            <a:off x="457200" y="960120"/>
-            <a:ext cx="10972800" cy="640080"/>
+            <a:off x="502920" y="1847088"/>
+            <a:ext cx="5394960" cy="1463039"/>
           </a:xfrm>
           <a:prstGeom prst="rect">
             <a:avLst/>
@@ -3755,47 +3579,11 @@
           </a:bodyPr>
           <a:lstStyle/>
           <a:p>
-            <a:pPr algn="l">
-              <a:defRPr sz="2800" b="1">
-                <a:solidFill>
-                  <a:srgbClr val="0F1E2D"/>
-                </a:solidFill>
-                <a:latin typeface="Calibri"/>
-              </a:defRPr>
-            </a:pPr>
-            <a:r>
-              <a:t>Good fares disappear before travelers can act</a:t>
-            </a:r>
-          </a:p>
-        </p:txBody>
-      </p:sp>
-      <p:sp>
-        <p:nvSpPr>
-          <p:cNvPr id="9" name="TextBox 8"/>
-          <p:cNvSpPr txBox="1"/>
-          <p:nvPr/>
-        </p:nvSpPr>
-        <p:spPr>
-          <a:xfrm>
-            <a:off x="548640" y="1828800"/>
-            <a:ext cx="10972800" cy="4114800"/>
-          </a:xfrm>
-          <a:prstGeom prst="rect">
-            <a:avLst/>
-          </a:prstGeom>
-          <a:noFill/>
-        </p:spPr>
-        <p:txBody>
-          <a:bodyPr wrap="square">
-            <a:spAutoFit/>
-          </a:bodyPr>
-          <a:lstStyle/>
-          <a:p>
             <a:pPr>
               <a:spcAft>
-                <a:spcPts val="1000"/>
+                <a:spcPts val="300"/>
               </a:spcAft>
-              <a:defRPr sz="1800">
+              <a:defRPr sz="1200">
                 <a:solidFill>
                   <a:srgbClr val="19232D"/>
                 </a:solidFill>
@@ -3803,15 +3591,15 @@
               </a:defRPr>
             </a:pPr>
             <a:r>
-              <a:t>•  Flight prices move in hours. Checking sites manually is slow and easy to miss.</a:t>
+              <a:t>• Fares move in hours — manual checking is too slow.</a:t>
             </a:r>
           </a:p>
           <a:p>
             <a:pPr>
               <a:spcAft>
-                <a:spcPts val="1000"/>
+                <a:spcPts val="300"/>
               </a:spcAft>
-              <a:defRPr sz="1800">
+              <a:defRPr sz="1200">
                 <a:solidFill>
                   <a:srgbClr val="19232D"/>
                 </a:solidFill>
@@ -3819,15 +3607,15 @@
               </a:defRPr>
             </a:pPr>
             <a:r>
-              <a:t>•  Generic deal feeds are noisy — they are not your route, dates or budget.</a:t>
+              <a:t>• Generic deal feeds are noisy (not your brief).</a:t>
             </a:r>
           </a:p>
           <a:p>
             <a:pPr>
               <a:spcAft>
-                <a:spcPts val="1000"/>
+                <a:spcPts val="300"/>
               </a:spcAft>
-              <a:defRPr sz="1800">
+              <a:defRPr sz="1200">
                 <a:solidFill>
                   <a:srgbClr val="19232D"/>
                 </a:solidFill>
@@ -3835,45 +3623,27 @@
               </a:defRPr>
             </a:pPr>
             <a:r>
-              <a:t>•  By the time you see a fare, seats and price are often already gone.</a:t>
-            </a:r>
-          </a:p>
-        </p:txBody>
-      </p:sp>
-    </p:spTree>
-  </p:cSld>
-  <p:clrMapOvr>
-    <a:masterClrMapping/>
-  </p:clrMapOvr>
-</p:sld>
-</file>
-
-<file path=ppt/slides/slide3.xml><?xml version="1.0" encoding="utf-8"?>
-<p:sld xmlns:a="http://schemas.openxmlformats.org/drawingml/2006/main" xmlns:p="http://schemas.openxmlformats.org/presentationml/2006/main" xmlns:r="http://schemas.openxmlformats.org/officeDocument/2006/relationships">
-  <p:cSld>
-    <p:spTree>
-      <p:nvGrpSpPr>
-        <p:cNvPr id="1" name=""/>
-        <p:cNvGrpSpPr/>
-        <p:nvPr/>
-      </p:nvGrpSpPr>
-      <p:grpSpPr/>
-      <p:sp>
-        <p:nvSpPr>
-          <p:cNvPr id="2" name="Rectangle 1"/>
+              <a:t>• When you finally see it, the fare is often gone.</a:t>
+            </a:r>
+          </a:p>
+        </p:txBody>
+      </p:sp>
+      <p:sp>
+        <p:nvSpPr>
+          <p:cNvPr id="14" name="Rounded Rectangle 13"/>
           <p:cNvSpPr/>
           <p:nvPr/>
         </p:nvSpPr>
         <p:spPr>
           <a:xfrm>
-            <a:off x="0" y="0"/>
-            <a:ext cx="12191695" cy="6858000"/>
-          </a:xfrm>
-          <a:prstGeom prst="rect">
+            <a:off x="6263640" y="1463040"/>
+            <a:ext cx="5577840" cy="1965960"/>
+          </a:xfrm>
+          <a:prstGeom prst="roundRect">
             <a:avLst/>
           </a:prstGeom>
           <a:solidFill>
-            <a:srgbClr val="FFFFFF"/>
+            <a:srgbClr val="F6F8FA"/>
           </a:solidFill>
           <a:ln>
             <a:noFill/>
@@ -3903,14 +3673,14 @@
       </p:sp>
       <p:sp>
         <p:nvSpPr>
-          <p:cNvPr id="3" name="Rectangle 2"/>
+          <p:cNvPr id="15" name="Rectangle 14"/>
           <p:cNvSpPr/>
           <p:nvPr/>
         </p:nvSpPr>
         <p:spPr>
           <a:xfrm>
-            <a:off x="0" y="0"/>
-            <a:ext cx="201168" cy="6858000"/>
+            <a:off x="6263640" y="1463040"/>
+            <a:ext cx="5577840" cy="45720"/>
           </a:xfrm>
           <a:prstGeom prst="rect">
             <a:avLst/>
@@ -3946,16 +3716,142 @@
       </p:sp>
       <p:sp>
         <p:nvSpPr>
-          <p:cNvPr id="4" name="Rectangle 3"/>
+          <p:cNvPr id="16" name="TextBox 15"/>
+          <p:cNvSpPr txBox="1"/>
+          <p:nvPr/>
+        </p:nvSpPr>
+        <p:spPr>
+          <a:xfrm>
+            <a:off x="6400800" y="1572768"/>
+            <a:ext cx="5303520" cy="256032"/>
+          </a:xfrm>
+          <a:prstGeom prst="rect">
+            <a:avLst/>
+          </a:prstGeom>
+          <a:noFill/>
+        </p:spPr>
+        <p:txBody>
+          <a:bodyPr wrap="square">
+            <a:spAutoFit/>
+          </a:bodyPr>
+          <a:lstStyle/>
+          <a:p>
+            <a:pPr algn="l">
+              <a:spcAft>
+                <a:spcPts val="200"/>
+              </a:spcAft>
+              <a:defRPr sz="1300" b="1">
+                <a:solidFill>
+                  <a:srgbClr val="006E82"/>
+                </a:solidFill>
+                <a:latin typeface="Calibri"/>
+              </a:defRPr>
+            </a:pPr>
+            <a:r>
+              <a:t>PRODUCT</a:t>
+            </a:r>
+          </a:p>
+        </p:txBody>
+      </p:sp>
+      <p:sp>
+        <p:nvSpPr>
+          <p:cNvPr id="17" name="TextBox 16"/>
+          <p:cNvSpPr txBox="1"/>
+          <p:nvPr/>
+        </p:nvSpPr>
+        <p:spPr>
+          <a:xfrm>
+            <a:off x="6400800" y="1847088"/>
+            <a:ext cx="5303520" cy="1463039"/>
+          </a:xfrm>
+          <a:prstGeom prst="rect">
+            <a:avLst/>
+          </a:prstGeom>
+          <a:noFill/>
+        </p:spPr>
+        <p:txBody>
+          <a:bodyPr wrap="square">
+            <a:spAutoFit/>
+          </a:bodyPr>
+          <a:lstStyle/>
+          <a:p>
+            <a:pPr>
+              <a:spcAft>
+                <a:spcPts val="300"/>
+              </a:spcAft>
+              <a:defRPr sz="1200">
+                <a:solidFill>
+                  <a:srgbClr val="19232D"/>
+                </a:solidFill>
+                <a:latin typeface="Calibri"/>
+              </a:defRPr>
+            </a:pPr>
+            <a:r>
+              <a:t>• You set: origin, destination, dates, max price.</a:t>
+            </a:r>
+          </a:p>
+          <a:p>
+            <a:pPr>
+              <a:spcAft>
+                <a:spcPts val="300"/>
+              </a:spcAft>
+              <a:defRPr sz="1200">
+                <a:solidFill>
+                  <a:srgbClr val="19232D"/>
+                </a:solidFill>
+                <a:latin typeface="Calibri"/>
+              </a:defRPr>
+            </a:pPr>
+            <a:r>
+              <a:t>• Fly456 monitors that exact brief.</a:t>
+            </a:r>
+          </a:p>
+          <a:p>
+            <a:pPr>
+              <a:spcAft>
+                <a:spcPts val="300"/>
+              </a:spcAft>
+              <a:defRPr sz="1200">
+                <a:solidFill>
+                  <a:srgbClr val="19232D"/>
+                </a:solidFill>
+                <a:latin typeface="Calibri"/>
+              </a:defRPr>
+            </a:pPr>
+            <a:r>
+              <a:t>• Telegram notifies you via @fly456bot to reserve fast.</a:t>
+            </a:r>
+          </a:p>
+          <a:p>
+            <a:pPr>
+              <a:spcAft>
+                <a:spcPts val="300"/>
+              </a:spcAft>
+              <a:defRPr sz="1200">
+                <a:solidFill>
+                  <a:srgbClr val="19232D"/>
+                </a:solidFill>
+                <a:latin typeface="Calibri"/>
+              </a:defRPr>
+            </a:pPr>
+            <a:r>
+              <a:t>• We don’t sell tickets — you book with airline/OTA.</a:t>
+            </a:r>
+          </a:p>
+        </p:txBody>
+      </p:sp>
+      <p:sp>
+        <p:nvSpPr>
+          <p:cNvPr id="18" name="Rounded Rectangle 17"/>
           <p:cNvSpPr/>
           <p:nvPr/>
         </p:nvSpPr>
         <p:spPr>
           <a:xfrm>
-            <a:off x="201168" y="0"/>
-            <a:ext cx="11990527" cy="411480"/>
-          </a:xfrm>
-          <a:prstGeom prst="rect">
+            <a:off x="365760" y="3566160"/>
+            <a:ext cx="5669280" cy="1417320"/>
+          </a:xfrm>
+          <a:prstGeom prst="roundRect">
             <a:avLst/>
           </a:prstGeom>
           <a:solidFill>
@@ -3989,164 +3885,20 @@
       </p:sp>
       <p:sp>
         <p:nvSpPr>
-          <p:cNvPr id="5" name="TextBox 4"/>
-          <p:cNvSpPr txBox="1"/>
+          <p:cNvPr id="19" name="Rectangle 18"/>
+          <p:cNvSpPr/>
           <p:nvPr/>
         </p:nvSpPr>
         <p:spPr>
           <a:xfrm>
-            <a:off x="411480" y="73152"/>
-            <a:ext cx="9144000" cy="274320"/>
+            <a:off x="365760" y="3566160"/>
+            <a:ext cx="5669280" cy="45720"/>
           </a:xfrm>
           <a:prstGeom prst="rect">
             <a:avLst/>
           </a:prstGeom>
-          <a:noFill/>
-        </p:spPr>
-        <p:txBody>
-          <a:bodyPr wrap="none">
-            <a:spAutoFit/>
-          </a:bodyPr>
-          <a:lstStyle/>
-          <a:p>
-            <a:pPr>
-              <a:defRPr sz="1100">
-                <a:solidFill>
-                  <a:srgbClr val="5F6E78"/>
-                </a:solidFill>
-                <a:latin typeface="Calibri"/>
-              </a:defRPr>
-            </a:pPr>
-            <a:r>
-              <a:t>Fly456  ·  Pre-seed note for Kima Ventures</a:t>
-            </a:r>
-          </a:p>
-        </p:txBody>
-      </p:sp>
-      <p:sp>
-        <p:nvSpPr>
-          <p:cNvPr id="6" name="TextBox 5"/>
-          <p:cNvSpPr txBox="1"/>
-          <p:nvPr/>
-        </p:nvSpPr>
-        <p:spPr>
-          <a:xfrm>
-            <a:off x="11155680" y="73152"/>
-            <a:ext cx="822960" cy="274320"/>
-          </a:xfrm>
-          <a:prstGeom prst="rect">
-            <a:avLst/>
-          </a:prstGeom>
-          <a:noFill/>
-        </p:spPr>
-        <p:txBody>
-          <a:bodyPr wrap="square">
-            <a:spAutoFit/>
-          </a:bodyPr>
-          <a:lstStyle/>
-          <a:p>
-            <a:pPr algn="r">
-              <a:defRPr sz="1100" b="0">
-                <a:solidFill>
-                  <a:srgbClr val="5F6E78"/>
-                </a:solidFill>
-                <a:latin typeface="Calibri"/>
-              </a:defRPr>
-            </a:pPr>
-            <a:r>
-              <a:t>3/6</a:t>
-            </a:r>
-          </a:p>
-        </p:txBody>
-      </p:sp>
-      <p:sp>
-        <p:nvSpPr>
-          <p:cNvPr id="7" name="TextBox 6"/>
-          <p:cNvSpPr txBox="1"/>
-          <p:nvPr/>
-        </p:nvSpPr>
-        <p:spPr>
-          <a:xfrm>
-            <a:off x="457200" y="640080"/>
-            <a:ext cx="10972800" cy="274320"/>
-          </a:xfrm>
-          <a:prstGeom prst="rect">
-            <a:avLst/>
-          </a:prstGeom>
-          <a:noFill/>
-        </p:spPr>
-        <p:txBody>
-          <a:bodyPr wrap="square">
-            <a:spAutoFit/>
-          </a:bodyPr>
-          <a:lstStyle/>
-          <a:p>
-            <a:pPr algn="l">
-              <a:defRPr sz="1200" b="1">
-                <a:solidFill>
-                  <a:srgbClr val="006E82"/>
-                </a:solidFill>
-                <a:latin typeface="Calibri"/>
-              </a:defRPr>
-            </a:pPr>
-            <a:r>
-              <a:t>SOLUTION</a:t>
-            </a:r>
-          </a:p>
-        </p:txBody>
-      </p:sp>
-      <p:sp>
-        <p:nvSpPr>
-          <p:cNvPr id="8" name="TextBox 7"/>
-          <p:cNvSpPr txBox="1"/>
-          <p:nvPr/>
-        </p:nvSpPr>
-        <p:spPr>
-          <a:xfrm>
-            <a:off x="457200" y="960120"/>
-            <a:ext cx="10972800" cy="640080"/>
-          </a:xfrm>
-          <a:prstGeom prst="rect">
-            <a:avLst/>
-          </a:prstGeom>
-          <a:noFill/>
-        </p:spPr>
-        <p:txBody>
-          <a:bodyPr wrap="square">
-            <a:spAutoFit/>
-          </a:bodyPr>
-          <a:lstStyle/>
-          <a:p>
-            <a:pPr algn="l">
-              <a:defRPr sz="2800" b="1">
-                <a:solidFill>
-                  <a:srgbClr val="0F1E2D"/>
-                </a:solidFill>
-                <a:latin typeface="Calibri"/>
-              </a:defRPr>
-            </a:pPr>
-            <a:r>
-              <a:t>Named monitoring + Telegram alert to book fast</a:t>
-            </a:r>
-          </a:p>
-        </p:txBody>
-      </p:sp>
-      <p:sp>
-        <p:nvSpPr>
-          <p:cNvPr id="9" name="Rounded Rectangle 8"/>
-          <p:cNvSpPr/>
-          <p:nvPr/>
-        </p:nvSpPr>
-        <p:spPr>
-          <a:xfrm>
-            <a:off x="457200" y="1828800"/>
-            <a:ext cx="3657600" cy="3840480"/>
-          </a:xfrm>
-          <a:prstGeom prst="roundRect">
-            <a:avLst/>
-          </a:prstGeom>
           <a:solidFill>
-            <a:srgbClr val="F6F8FA"/>
+            <a:srgbClr val="006E82"/>
           </a:solidFill>
           <a:ln>
             <a:noFill/>
@@ -4176,20 +3928,114 @@
       </p:sp>
       <p:sp>
         <p:nvSpPr>
-          <p:cNvPr id="10" name="Rectangle 9"/>
-          <p:cNvSpPr/>
+          <p:cNvPr id="20" name="TextBox 19"/>
+          <p:cNvSpPr txBox="1"/>
           <p:nvPr/>
         </p:nvSpPr>
         <p:spPr>
           <a:xfrm>
-            <a:off x="457200" y="1828800"/>
-            <a:ext cx="3657600" cy="54864"/>
+            <a:off x="502920" y="3675887"/>
+            <a:ext cx="5394960" cy="256032"/>
           </a:xfrm>
           <a:prstGeom prst="rect">
             <a:avLst/>
           </a:prstGeom>
+          <a:noFill/>
+        </p:spPr>
+        <p:txBody>
+          <a:bodyPr wrap="square">
+            <a:spAutoFit/>
+          </a:bodyPr>
+          <a:lstStyle/>
+          <a:p>
+            <a:pPr algn="l">
+              <a:spcAft>
+                <a:spcPts val="200"/>
+              </a:spcAft>
+              <a:defRPr sz="1300" b="1">
+                <a:solidFill>
+                  <a:srgbClr val="006E82"/>
+                </a:solidFill>
+                <a:latin typeface="Calibri"/>
+              </a:defRPr>
+            </a:pPr>
+            <a:r>
+              <a:t>FLY456 ECONOMY</a:t>
+            </a:r>
+          </a:p>
+        </p:txBody>
+      </p:sp>
+      <p:sp>
+        <p:nvSpPr>
+          <p:cNvPr id="21" name="TextBox 20"/>
+          <p:cNvSpPr txBox="1"/>
+          <p:nvPr/>
+        </p:nvSpPr>
+        <p:spPr>
+          <a:xfrm>
+            <a:off x="502920" y="3950208"/>
+            <a:ext cx="5394960" cy="914400"/>
+          </a:xfrm>
+          <a:prstGeom prst="rect">
+            <a:avLst/>
+          </a:prstGeom>
+          <a:noFill/>
+        </p:spPr>
+        <p:txBody>
+          <a:bodyPr wrap="square">
+            <a:spAutoFit/>
+          </a:bodyPr>
+          <a:lstStyle/>
+          <a:p>
+            <a:pPr>
+              <a:spcAft>
+                <a:spcPts val="300"/>
+              </a:spcAft>
+              <a:defRPr sz="1200">
+                <a:solidFill>
+                  <a:srgbClr val="19232D"/>
+                </a:solidFill>
+                <a:latin typeface="Calibri"/>
+              </a:defRPr>
+            </a:pPr>
+            <a:r>
+              <a:t>Economy-cabin monitoring for your named brief.</a:t>
+            </a:r>
+          </a:p>
+          <a:p>
+            <a:pPr>
+              <a:spcAft>
+                <a:spcPts val="300"/>
+              </a:spcAft>
+              <a:defRPr sz="1200">
+                <a:solidFill>
+                  <a:srgbClr val="19232D"/>
+                </a:solidFill>
+                <a:latin typeface="Calibri"/>
+              </a:defRPr>
+            </a:pPr>
+            <a:r>
+              <a:t>Pricing: 5€/month  ·  20€/year</a:t>
+            </a:r>
+          </a:p>
+        </p:txBody>
+      </p:sp>
+      <p:sp>
+        <p:nvSpPr>
+          <p:cNvPr id="22" name="Rounded Rectangle 21"/>
+          <p:cNvSpPr/>
+          <p:nvPr/>
+        </p:nvSpPr>
+        <p:spPr>
+          <a:xfrm>
+            <a:off x="6263640" y="3566160"/>
+            <a:ext cx="5577840" cy="1417320"/>
+          </a:xfrm>
+          <a:prstGeom prst="roundRect">
+            <a:avLst/>
+          </a:prstGeom>
           <a:solidFill>
-            <a:srgbClr val="006E82"/>
+            <a:srgbClr val="F6F8FA"/>
           </a:solidFill>
           <a:ln>
             <a:noFill/>
@@ -4219,172 +4065,20 @@
       </p:sp>
       <p:sp>
         <p:nvSpPr>
-          <p:cNvPr id="11" name="TextBox 10"/>
-          <p:cNvSpPr txBox="1"/>
+          <p:cNvPr id="23" name="Rectangle 22"/>
+          <p:cNvSpPr/>
           <p:nvPr/>
         </p:nvSpPr>
         <p:spPr>
           <a:xfrm>
-            <a:off x="640080" y="2011680"/>
-            <a:ext cx="3291840" cy="320040"/>
+            <a:off x="6263640" y="3566160"/>
+            <a:ext cx="5577840" cy="45720"/>
           </a:xfrm>
           <a:prstGeom prst="rect">
             <a:avLst/>
           </a:prstGeom>
-          <a:noFill/>
-        </p:spPr>
-        <p:txBody>
-          <a:bodyPr wrap="square">
-            <a:spAutoFit/>
-          </a:bodyPr>
-          <a:lstStyle/>
-          <a:p>
-            <a:pPr algn="l">
-              <a:defRPr sz="1600" b="1">
-                <a:solidFill>
-                  <a:srgbClr val="0F1E2D"/>
-                </a:solidFill>
-                <a:latin typeface="Calibri"/>
-              </a:defRPr>
-            </a:pPr>
-            <a:r>
-              <a:t>You define the flight</a:t>
-            </a:r>
-          </a:p>
-        </p:txBody>
-      </p:sp>
-      <p:sp>
-        <p:nvSpPr>
-          <p:cNvPr id="12" name="TextBox 11"/>
-          <p:cNvSpPr txBox="1"/>
-          <p:nvPr/>
-        </p:nvSpPr>
-        <p:spPr>
-          <a:xfrm>
-            <a:off x="640080" y="2377440"/>
-            <a:ext cx="3291840" cy="3108960"/>
-          </a:xfrm>
-          <a:prstGeom prst="rect">
-            <a:avLst/>
-          </a:prstGeom>
-          <a:noFill/>
-        </p:spPr>
-        <p:txBody>
-          <a:bodyPr wrap="square">
-            <a:spAutoFit/>
-          </a:bodyPr>
-          <a:lstStyle/>
-          <a:p>
-            <a:pPr>
-              <a:spcAft>
-                <a:spcPts val="400"/>
-              </a:spcAft>
-              <a:defRPr sz="1300">
-                <a:solidFill>
-                  <a:srgbClr val="19232D"/>
-                </a:solidFill>
-                <a:latin typeface="Calibri"/>
-              </a:defRPr>
-            </a:pPr>
-            <a:r>
-              <a:t>Origin</a:t>
-            </a:r>
-          </a:p>
-          <a:p>
-            <a:pPr>
-              <a:spcAft>
-                <a:spcPts val="400"/>
-              </a:spcAft>
-              <a:defRPr sz="1300">
-                <a:solidFill>
-                  <a:srgbClr val="19232D"/>
-                </a:solidFill>
-                <a:latin typeface="Calibri"/>
-              </a:defRPr>
-            </a:pPr>
-            <a:r>
-              <a:t>Destination</a:t>
-            </a:r>
-          </a:p>
-          <a:p>
-            <a:pPr>
-              <a:spcAft>
-                <a:spcPts val="400"/>
-              </a:spcAft>
-              <a:defRPr sz="1300">
-                <a:solidFill>
-                  <a:srgbClr val="19232D"/>
-                </a:solidFill>
-                <a:latin typeface="Calibri"/>
-              </a:defRPr>
-            </a:pPr>
-            <a:r>
-              <a:t>Dates</a:t>
-            </a:r>
-          </a:p>
-          <a:p>
-            <a:pPr>
-              <a:spcAft>
-                <a:spcPts val="400"/>
-              </a:spcAft>
-              <a:defRPr sz="1300">
-                <a:solidFill>
-                  <a:srgbClr val="19232D"/>
-                </a:solidFill>
-                <a:latin typeface="Calibri"/>
-              </a:defRPr>
-            </a:pPr>
-            <a:r>
-              <a:t>Maximum price</a:t>
-            </a:r>
-          </a:p>
-          <a:p>
-            <a:pPr>
-              <a:spcAft>
-                <a:spcPts val="400"/>
-              </a:spcAft>
-              <a:defRPr sz="1300">
-                <a:solidFill>
-                  <a:srgbClr val="19232D"/>
-                </a:solidFill>
-                <a:latin typeface="Calibri"/>
-              </a:defRPr>
-            </a:pPr>
-          </a:p>
-          <a:p>
-            <a:pPr>
-              <a:spcAft>
-                <a:spcPts val="400"/>
-              </a:spcAft>
-              <a:defRPr sz="1300">
-                <a:solidFill>
-                  <a:srgbClr val="19232D"/>
-                </a:solidFill>
-                <a:latin typeface="Calibri"/>
-              </a:defRPr>
-            </a:pPr>
-            <a:r>
-              <a:t>Fly456 watches that exact brief.</a:t>
-            </a:r>
-          </a:p>
-        </p:txBody>
-      </p:sp>
-      <p:sp>
-        <p:nvSpPr>
-          <p:cNvPr id="13" name="Rounded Rectangle 12"/>
-          <p:cNvSpPr/>
-          <p:nvPr/>
-        </p:nvSpPr>
-        <p:spPr>
-          <a:xfrm>
-            <a:off x="4343400" y="1828800"/>
-            <a:ext cx="3657600" cy="3840480"/>
-          </a:xfrm>
-          <a:prstGeom prst="roundRect">
-            <a:avLst/>
-          </a:prstGeom>
           <a:solidFill>
-            <a:srgbClr val="F6F8FA"/>
+            <a:srgbClr val="006E82"/>
           </a:solidFill>
           <a:ln>
             <a:noFill/>
@@ -4414,20 +4108,114 @@
       </p:sp>
       <p:sp>
         <p:nvSpPr>
-          <p:cNvPr id="14" name="Rectangle 13"/>
-          <p:cNvSpPr/>
+          <p:cNvPr id="24" name="TextBox 23"/>
+          <p:cNvSpPr txBox="1"/>
           <p:nvPr/>
         </p:nvSpPr>
         <p:spPr>
           <a:xfrm>
-            <a:off x="4343400" y="1828800"/>
-            <a:ext cx="3657600" cy="54864"/>
+            <a:off x="6400800" y="3675887"/>
+            <a:ext cx="5303520" cy="256032"/>
           </a:xfrm>
           <a:prstGeom prst="rect">
             <a:avLst/>
           </a:prstGeom>
+          <a:noFill/>
+        </p:spPr>
+        <p:txBody>
+          <a:bodyPr wrap="square">
+            <a:spAutoFit/>
+          </a:bodyPr>
+          <a:lstStyle/>
+          <a:p>
+            <a:pPr algn="l">
+              <a:spcAft>
+                <a:spcPts val="200"/>
+              </a:spcAft>
+              <a:defRPr sz="1300" b="1">
+                <a:solidFill>
+                  <a:srgbClr val="006E82"/>
+                </a:solidFill>
+                <a:latin typeface="Calibri"/>
+              </a:defRPr>
+            </a:pPr>
+            <a:r>
+              <a:t>FLY456 BUSINESS</a:t>
+            </a:r>
+          </a:p>
+        </p:txBody>
+      </p:sp>
+      <p:sp>
+        <p:nvSpPr>
+          <p:cNvPr id="25" name="TextBox 24"/>
+          <p:cNvSpPr txBox="1"/>
+          <p:nvPr/>
+        </p:nvSpPr>
+        <p:spPr>
+          <a:xfrm>
+            <a:off x="6400800" y="3950208"/>
+            <a:ext cx="5303520" cy="914400"/>
+          </a:xfrm>
+          <a:prstGeom prst="rect">
+            <a:avLst/>
+          </a:prstGeom>
+          <a:noFill/>
+        </p:spPr>
+        <p:txBody>
+          <a:bodyPr wrap="square">
+            <a:spAutoFit/>
+          </a:bodyPr>
+          <a:lstStyle/>
+          <a:p>
+            <a:pPr>
+              <a:spcAft>
+                <a:spcPts val="300"/>
+              </a:spcAft>
+              <a:defRPr sz="1200">
+                <a:solidFill>
+                  <a:srgbClr val="19232D"/>
+                </a:solidFill>
+                <a:latin typeface="Calibri"/>
+              </a:defRPr>
+            </a:pPr>
+            <a:r>
+              <a:t>Business-cabin monitoring for your named brief.</a:t>
+            </a:r>
+          </a:p>
+          <a:p>
+            <a:pPr>
+              <a:spcAft>
+                <a:spcPts val="300"/>
+              </a:spcAft>
+              <a:defRPr sz="1200">
+                <a:solidFill>
+                  <a:srgbClr val="19232D"/>
+                </a:solidFill>
+                <a:latin typeface="Calibri"/>
+              </a:defRPr>
+            </a:pPr>
+            <a:r>
+              <a:t>Pricing: 12€/month  ·  99€/year</a:t>
+            </a:r>
+          </a:p>
+        </p:txBody>
+      </p:sp>
+      <p:sp>
+        <p:nvSpPr>
+          <p:cNvPr id="26" name="Rounded Rectangle 25"/>
+          <p:cNvSpPr/>
+          <p:nvPr/>
+        </p:nvSpPr>
+        <p:spPr>
+          <a:xfrm>
+            <a:off x="365760" y="5120640"/>
+            <a:ext cx="5669280" cy="1463040"/>
+          </a:xfrm>
+          <a:prstGeom prst="roundRect">
+            <a:avLst/>
+          </a:prstGeom>
           <a:solidFill>
-            <a:srgbClr val="006E82"/>
+            <a:srgbClr val="F6F8FA"/>
           </a:solidFill>
           <a:ln>
             <a:noFill/>
@@ -4457,172 +4245,20 @@
       </p:sp>
       <p:sp>
         <p:nvSpPr>
-          <p:cNvPr id="15" name="TextBox 14"/>
-          <p:cNvSpPr txBox="1"/>
+          <p:cNvPr id="27" name="Rectangle 26"/>
+          <p:cNvSpPr/>
           <p:nvPr/>
         </p:nvSpPr>
         <p:spPr>
           <a:xfrm>
-            <a:off x="4526280" y="2011680"/>
-            <a:ext cx="3291840" cy="320040"/>
+            <a:off x="365760" y="5120640"/>
+            <a:ext cx="5669280" cy="45720"/>
           </a:xfrm>
           <a:prstGeom prst="rect">
             <a:avLst/>
           </a:prstGeom>
-          <a:noFill/>
-        </p:spPr>
-        <p:txBody>
-          <a:bodyPr wrap="square">
-            <a:spAutoFit/>
-          </a:bodyPr>
-          <a:lstStyle/>
-          <a:p>
-            <a:pPr algn="l">
-              <a:defRPr sz="1600" b="1">
-                <a:solidFill>
-                  <a:srgbClr val="0F1E2D"/>
-                </a:solidFill>
-                <a:latin typeface="Calibri"/>
-              </a:defRPr>
-            </a:pPr>
-            <a:r>
-              <a:t>We notify on Telegram</a:t>
-            </a:r>
-          </a:p>
-        </p:txBody>
-      </p:sp>
-      <p:sp>
-        <p:nvSpPr>
-          <p:cNvPr id="16" name="TextBox 15"/>
-          <p:cNvSpPr txBox="1"/>
-          <p:nvPr/>
-        </p:nvSpPr>
-        <p:spPr>
-          <a:xfrm>
-            <a:off x="4526280" y="2377440"/>
-            <a:ext cx="3291840" cy="3108960"/>
-          </a:xfrm>
-          <a:prstGeom prst="rect">
-            <a:avLst/>
-          </a:prstGeom>
-          <a:noFill/>
-        </p:spPr>
-        <p:txBody>
-          <a:bodyPr wrap="square">
-            <a:spAutoFit/>
-          </a:bodyPr>
-          <a:lstStyle/>
-          <a:p>
-            <a:pPr>
-              <a:spcAft>
-                <a:spcPts val="400"/>
-              </a:spcAft>
-              <a:defRPr sz="1300">
-                <a:solidFill>
-                  <a:srgbClr val="19232D"/>
-                </a:solidFill>
-                <a:latin typeface="Calibri"/>
-              </a:defRPr>
-            </a:pPr>
-            <a:r>
-              <a:t>Alert lands in your Telegram inbox</a:t>
-            </a:r>
-          </a:p>
-          <a:p>
-            <a:pPr>
-              <a:spcAft>
-                <a:spcPts val="400"/>
-              </a:spcAft>
-              <a:defRPr sz="1300">
-                <a:solidFill>
-                  <a:srgbClr val="19232D"/>
-                </a:solidFill>
-                <a:latin typeface="Calibri"/>
-              </a:defRPr>
-            </a:pPr>
-            <a:r>
-              <a:t>via @fly456bot</a:t>
-            </a:r>
-          </a:p>
-          <a:p>
-            <a:pPr>
-              <a:spcAft>
-                <a:spcPts val="400"/>
-              </a:spcAft>
-              <a:defRPr sz="1300">
-                <a:solidFill>
-                  <a:srgbClr val="19232D"/>
-                </a:solidFill>
-                <a:latin typeface="Calibri"/>
-              </a:defRPr>
-            </a:pPr>
-            <a:r>
-              <a:t>Built to help you reserve fast</a:t>
-            </a:r>
-          </a:p>
-          <a:p>
-            <a:pPr>
-              <a:spcAft>
-                <a:spcPts val="400"/>
-              </a:spcAft>
-              <a:defRPr sz="1300">
-                <a:solidFill>
-                  <a:srgbClr val="19232D"/>
-                </a:solidFill>
-                <a:latin typeface="Calibri"/>
-              </a:defRPr>
-            </a:pPr>
-            <a:r>
-              <a:t>before the fare moves again</a:t>
-            </a:r>
-          </a:p>
-          <a:p>
-            <a:pPr>
-              <a:spcAft>
-                <a:spcPts val="400"/>
-              </a:spcAft>
-              <a:defRPr sz="1300">
-                <a:solidFill>
-                  <a:srgbClr val="19232D"/>
-                </a:solidFill>
-                <a:latin typeface="Calibri"/>
-              </a:defRPr>
-            </a:pPr>
-          </a:p>
-          <a:p>
-            <a:pPr>
-              <a:spcAft>
-                <a:spcPts val="400"/>
-              </a:spcAft>
-              <a:defRPr sz="1300">
-                <a:solidFill>
-                  <a:srgbClr val="19232D"/>
-                </a:solidFill>
-                <a:latin typeface="Calibri"/>
-              </a:defRPr>
-            </a:pPr>
-            <a:r>
-              <a:t>We do not sell tickets.</a:t>
-            </a:r>
-          </a:p>
-        </p:txBody>
-      </p:sp>
-      <p:sp>
-        <p:nvSpPr>
-          <p:cNvPr id="17" name="Rounded Rectangle 16"/>
-          <p:cNvSpPr/>
-          <p:nvPr/>
-        </p:nvSpPr>
-        <p:spPr>
-          <a:xfrm>
-            <a:off x="8229600" y="1828800"/>
-            <a:ext cx="3474720" cy="3840480"/>
-          </a:xfrm>
-          <a:prstGeom prst="roundRect">
-            <a:avLst/>
-          </a:prstGeom>
           <a:solidFill>
-            <a:srgbClr val="F6F8FA"/>
+            <a:srgbClr val="006E82"/>
           </a:solidFill>
           <a:ln>
             <a:noFill/>
@@ -4652,20 +4288,130 @@
       </p:sp>
       <p:sp>
         <p:nvSpPr>
-          <p:cNvPr id="18" name="Rectangle 17"/>
-          <p:cNvSpPr/>
+          <p:cNvPr id="28" name="TextBox 27"/>
+          <p:cNvSpPr txBox="1"/>
           <p:nvPr/>
         </p:nvSpPr>
         <p:spPr>
           <a:xfrm>
-            <a:off x="8229600" y="1828800"/>
-            <a:ext cx="3474720" cy="54864"/>
+            <a:off x="502920" y="5230368"/>
+            <a:ext cx="5394960" cy="256032"/>
           </a:xfrm>
           <a:prstGeom prst="rect">
             <a:avLst/>
           </a:prstGeom>
+          <a:noFill/>
+        </p:spPr>
+        <p:txBody>
+          <a:bodyPr wrap="square">
+            <a:spAutoFit/>
+          </a:bodyPr>
+          <a:lstStyle/>
+          <a:p>
+            <a:pPr algn="l">
+              <a:spcAft>
+                <a:spcPts val="200"/>
+              </a:spcAft>
+              <a:defRPr sz="1300" b="1">
+                <a:solidFill>
+                  <a:srgbClr val="006E82"/>
+                </a:solidFill>
+                <a:latin typeface="Calibri"/>
+              </a:defRPr>
+            </a:pPr>
+            <a:r>
+              <a:t>TRACTION (JUL 2026 LAUNCH · NO ADS)</a:t>
+            </a:r>
+          </a:p>
+        </p:txBody>
+      </p:sp>
+      <p:sp>
+        <p:nvSpPr>
+          <p:cNvPr id="29" name="TextBox 28"/>
+          <p:cNvSpPr txBox="1"/>
+          <p:nvPr/>
+        </p:nvSpPr>
+        <p:spPr>
+          <a:xfrm>
+            <a:off x="502920" y="5504688"/>
+            <a:ext cx="5394960" cy="960120"/>
+          </a:xfrm>
+          <a:prstGeom prst="rect">
+            <a:avLst/>
+          </a:prstGeom>
+          <a:noFill/>
+        </p:spPr>
+        <p:txBody>
+          <a:bodyPr wrap="square">
+            <a:spAutoFit/>
+          </a:bodyPr>
+          <a:lstStyle/>
+          <a:p>
+            <a:pPr>
+              <a:spcAft>
+                <a:spcPts val="300"/>
+              </a:spcAft>
+              <a:defRPr sz="1200">
+                <a:solidFill>
+                  <a:srgbClr val="19232D"/>
+                </a:solidFill>
+                <a:latin typeface="Calibri"/>
+              </a:defRPr>
+            </a:pPr>
+            <a:r>
+              <a:t>• 6 free Telegram channels (LatAm expats in EU/US).</a:t>
+            </a:r>
+          </a:p>
+          <a:p>
+            <a:pPr>
+              <a:spcAft>
+                <a:spcPts val="300"/>
+              </a:spcAft>
+              <a:defRPr sz="1200">
+                <a:solidFill>
+                  <a:srgbClr val="19232D"/>
+                </a:solidFill>
+                <a:latin typeface="Calibri"/>
+              </a:defRPr>
+            </a:pPr>
+            <a:r>
+              <a:t>• Early Premium — few paying subscribers so far.</a:t>
+            </a:r>
+          </a:p>
+          <a:p>
+            <a:pPr>
+              <a:spcAft>
+                <a:spcPts val="300"/>
+              </a:spcAft>
+              <a:defRPr sz="1200">
+                <a:solidFill>
+                  <a:srgbClr val="19232D"/>
+                </a:solidFill>
+                <a:latin typeface="Calibri"/>
+              </a:defRPr>
+            </a:pPr>
+            <a:r>
+              <a:t>• Live: fly456.com + @fly456bot (Stripe in Telegram).</a:t>
+            </a:r>
+          </a:p>
+        </p:txBody>
+      </p:sp>
+      <p:sp>
+        <p:nvSpPr>
+          <p:cNvPr id="30" name="Rounded Rectangle 29"/>
+          <p:cNvSpPr/>
+          <p:nvPr/>
+        </p:nvSpPr>
+        <p:spPr>
+          <a:xfrm>
+            <a:off x="6263640" y="5120640"/>
+            <a:ext cx="5577840" cy="1463040"/>
+          </a:xfrm>
+          <a:prstGeom prst="roundRect">
+            <a:avLst/>
+          </a:prstGeom>
           <a:solidFill>
-            <a:srgbClr val="006E82"/>
+            <a:srgbClr val="F6F8FA"/>
           </a:solidFill>
           <a:ln>
             <a:noFill/>
@@ -4695,203 +4441,20 @@
       </p:sp>
       <p:sp>
         <p:nvSpPr>
-          <p:cNvPr id="19" name="TextBox 18"/>
-          <p:cNvSpPr txBox="1"/>
-          <p:nvPr/>
-        </p:nvSpPr>
-        <p:spPr>
-          <a:xfrm>
-            <a:off x="8412480" y="2011680"/>
-            <a:ext cx="3108960" cy="320040"/>
-          </a:xfrm>
-          <a:prstGeom prst="rect">
-            <a:avLst/>
-          </a:prstGeom>
-          <a:noFill/>
-        </p:spPr>
-        <p:txBody>
-          <a:bodyPr wrap="square">
-            <a:spAutoFit/>
-          </a:bodyPr>
-          <a:lstStyle/>
-          <a:p>
-            <a:pPr algn="l">
-              <a:defRPr sz="1600" b="1">
-                <a:solidFill>
-                  <a:srgbClr val="0F1E2D"/>
-                </a:solidFill>
-                <a:latin typeface="Calibri"/>
-              </a:defRPr>
-            </a:pPr>
-            <a:r>
-              <a:t>Two cabin products</a:t>
-            </a:r>
-          </a:p>
-        </p:txBody>
-      </p:sp>
-      <p:sp>
-        <p:nvSpPr>
-          <p:cNvPr id="20" name="TextBox 19"/>
-          <p:cNvSpPr txBox="1"/>
-          <p:nvPr/>
-        </p:nvSpPr>
-        <p:spPr>
-          <a:xfrm>
-            <a:off x="8412480" y="2377440"/>
-            <a:ext cx="3108960" cy="3108960"/>
-          </a:xfrm>
-          <a:prstGeom prst="rect">
-            <a:avLst/>
-          </a:prstGeom>
-          <a:noFill/>
-        </p:spPr>
-        <p:txBody>
-          <a:bodyPr wrap="square">
-            <a:spAutoFit/>
-          </a:bodyPr>
-          <a:lstStyle/>
-          <a:p>
-            <a:pPr>
-              <a:spcAft>
-                <a:spcPts val="400"/>
-              </a:spcAft>
-              <a:defRPr sz="1300">
-                <a:solidFill>
-                  <a:srgbClr val="19232D"/>
-                </a:solidFill>
-                <a:latin typeface="Calibri"/>
-              </a:defRPr>
-            </a:pPr>
-            <a:r>
-              <a:t>Economy — monitor economy</a:t>
-            </a:r>
-          </a:p>
-          <a:p>
-            <a:pPr>
-              <a:spcAft>
-                <a:spcPts val="400"/>
-              </a:spcAft>
-              <a:defRPr sz="1300">
-                <a:solidFill>
-                  <a:srgbClr val="19232D"/>
-                </a:solidFill>
-                <a:latin typeface="Calibri"/>
-              </a:defRPr>
-            </a:pPr>
-            <a:r>
-              <a:t>cabin fares for your route</a:t>
-            </a:r>
-          </a:p>
-          <a:p>
-            <a:pPr>
-              <a:spcAft>
-                <a:spcPts val="400"/>
-              </a:spcAft>
-              <a:defRPr sz="1300">
-                <a:solidFill>
-                  <a:srgbClr val="19232D"/>
-                </a:solidFill>
-                <a:latin typeface="Calibri"/>
-              </a:defRPr>
-            </a:pPr>
-          </a:p>
-          <a:p>
-            <a:pPr>
-              <a:spcAft>
-                <a:spcPts val="400"/>
-              </a:spcAft>
-              <a:defRPr sz="1300">
-                <a:solidFill>
-                  <a:srgbClr val="19232D"/>
-                </a:solidFill>
-                <a:latin typeface="Calibri"/>
-              </a:defRPr>
-            </a:pPr>
-            <a:r>
-              <a:t>Business — monitor business</a:t>
-            </a:r>
-          </a:p>
-          <a:p>
-            <a:pPr>
-              <a:spcAft>
-                <a:spcPts val="400"/>
-              </a:spcAft>
-              <a:defRPr sz="1300">
-                <a:solidFill>
-                  <a:srgbClr val="19232D"/>
-                </a:solidFill>
-                <a:latin typeface="Calibri"/>
-              </a:defRPr>
-            </a:pPr>
-            <a:r>
-              <a:t>cabin fares for your route</a:t>
-            </a:r>
-          </a:p>
-          <a:p>
-            <a:pPr>
-              <a:spcAft>
-                <a:spcPts val="400"/>
-              </a:spcAft>
-              <a:defRPr sz="1300">
-                <a:solidFill>
-                  <a:srgbClr val="19232D"/>
-                </a:solidFill>
-                <a:latin typeface="Calibri"/>
-              </a:defRPr>
-            </a:pPr>
-          </a:p>
-          <a:p>
-            <a:pPr>
-              <a:spcAft>
-                <a:spcPts val="400"/>
-              </a:spcAft>
-              <a:defRPr sz="1300">
-                <a:solidFill>
-                  <a:srgbClr val="19232D"/>
-                </a:solidFill>
-                <a:latin typeface="Calibri"/>
-              </a:defRPr>
-            </a:pPr>
-            <a:r>
-              <a:t>Same alert logic, different cabin.</a:t>
-            </a:r>
-          </a:p>
-        </p:txBody>
-      </p:sp>
-    </p:spTree>
-  </p:cSld>
-  <p:clrMapOvr>
-    <a:masterClrMapping/>
-  </p:clrMapOvr>
-</p:sld>
-</file>
-
-<file path=ppt/slides/slide4.xml><?xml version="1.0" encoding="utf-8"?>
-<p:sld xmlns:a="http://schemas.openxmlformats.org/drawingml/2006/main" xmlns:p="http://schemas.openxmlformats.org/presentationml/2006/main" xmlns:r="http://schemas.openxmlformats.org/officeDocument/2006/relationships">
-  <p:cSld>
-    <p:spTree>
-      <p:nvGrpSpPr>
-        <p:cNvPr id="1" name=""/>
-        <p:cNvGrpSpPr/>
-        <p:nvPr/>
-      </p:nvGrpSpPr>
-      <p:grpSpPr/>
-      <p:sp>
-        <p:nvSpPr>
-          <p:cNvPr id="2" name="Rectangle 1"/>
+          <p:cNvPr id="31" name="Rectangle 30"/>
           <p:cNvSpPr/>
           <p:nvPr/>
         </p:nvSpPr>
         <p:spPr>
           <a:xfrm>
-            <a:off x="0" y="0"/>
-            <a:ext cx="12191695" cy="6858000"/>
+            <a:off x="6263640" y="5120640"/>
+            <a:ext cx="5577840" cy="45720"/>
           </a:xfrm>
           <a:prstGeom prst="rect">
             <a:avLst/>
           </a:prstGeom>
           <a:solidFill>
-            <a:srgbClr val="FFFFFF"/>
+            <a:srgbClr val="006E82"/>
           </a:solidFill>
           <a:ln>
             <a:noFill/>
@@ -4921,20 +4484,130 @@
       </p:sp>
       <p:sp>
         <p:nvSpPr>
-          <p:cNvPr id="3" name="Rectangle 2"/>
+          <p:cNvPr id="32" name="TextBox 31"/>
+          <p:cNvSpPr txBox="1"/>
+          <p:nvPr/>
+        </p:nvSpPr>
+        <p:spPr>
+          <a:xfrm>
+            <a:off x="6400800" y="5230368"/>
+            <a:ext cx="5303520" cy="256032"/>
+          </a:xfrm>
+          <a:prstGeom prst="rect">
+            <a:avLst/>
+          </a:prstGeom>
+          <a:noFill/>
+        </p:spPr>
+        <p:txBody>
+          <a:bodyPr wrap="square">
+            <a:spAutoFit/>
+          </a:bodyPr>
+          <a:lstStyle/>
+          <a:p>
+            <a:pPr algn="l">
+              <a:spcAft>
+                <a:spcPts val="200"/>
+              </a:spcAft>
+              <a:defRPr sz="1300" b="1">
+                <a:solidFill>
+                  <a:srgbClr val="006E82"/>
+                </a:solidFill>
+                <a:latin typeface="Calibri"/>
+              </a:defRPr>
+            </a:pPr>
+            <a:r>
+              <a:t>USE OF FUNDS (~€150k)</a:t>
+            </a:r>
+          </a:p>
+        </p:txBody>
+      </p:sp>
+      <p:sp>
+        <p:nvSpPr>
+          <p:cNvPr id="33" name="TextBox 32"/>
+          <p:cNvSpPr txBox="1"/>
+          <p:nvPr/>
+        </p:nvSpPr>
+        <p:spPr>
+          <a:xfrm>
+            <a:off x="6400800" y="5504688"/>
+            <a:ext cx="5303520" cy="960120"/>
+          </a:xfrm>
+          <a:prstGeom prst="rect">
+            <a:avLst/>
+          </a:prstGeom>
+          <a:noFill/>
+        </p:spPr>
+        <p:txBody>
+          <a:bodyPr wrap="square">
+            <a:spAutoFit/>
+          </a:bodyPr>
+          <a:lstStyle/>
+          <a:p>
+            <a:pPr>
+              <a:spcAft>
+                <a:spcPts val="300"/>
+              </a:spcAft>
+              <a:defRPr sz="1200">
+                <a:solidFill>
+                  <a:srgbClr val="19232D"/>
+                </a:solidFill>
+                <a:latin typeface="Calibri"/>
+              </a:defRPr>
+            </a:pPr>
+            <a:r>
+              <a:t>• BizDev hire  ·  paid acquisition tests</a:t>
+            </a:r>
+          </a:p>
+          <a:p>
+            <a:pPr>
+              <a:spcAft>
+                <a:spcPts val="300"/>
+              </a:spcAft>
+              <a:defRPr sz="1200">
+                <a:solidFill>
+                  <a:srgbClr val="19232D"/>
+                </a:solidFill>
+                <a:latin typeface="Calibri"/>
+              </a:defRPr>
+            </a:pPr>
+            <a:r>
+              <a:t>• Free → Premium conversion  ·  affiliate pilots</a:t>
+            </a:r>
+          </a:p>
+          <a:p>
+            <a:pPr>
+              <a:spcAft>
+                <a:spcPts val="300"/>
+              </a:spcAft>
+              <a:defRPr sz="1200">
+                <a:solidFill>
+                  <a:srgbClr val="19232D"/>
+                </a:solidFill>
+                <a:latin typeface="Calibri"/>
+              </a:defRPr>
+            </a:pPr>
+            <a:r>
+              <a:t>• Prove LTV/CAC with low burn</a:t>
+            </a:r>
+          </a:p>
+        </p:txBody>
+      </p:sp>
+      <p:sp>
+        <p:nvSpPr>
+          <p:cNvPr id="34" name="Rectangle 33"/>
           <p:cNvSpPr/>
           <p:nvPr/>
         </p:nvSpPr>
         <p:spPr>
           <a:xfrm>
-            <a:off x="0" y="0"/>
-            <a:ext cx="201168" cy="6858000"/>
+            <a:off x="164592" y="6601968"/>
+            <a:ext cx="12027103" cy="256032"/>
           </a:xfrm>
           <a:prstGeom prst="rect">
             <a:avLst/>
           </a:prstGeom>
           <a:solidFill>
-            <a:srgbClr val="006E82"/>
+            <a:srgbClr val="0F1E2D"/>
           </a:solidFill>
           <a:ln>
             <a:noFill/>
@@ -4964,57 +4637,14 @@
       </p:sp>
       <p:sp>
         <p:nvSpPr>
-          <p:cNvPr id="4" name="Rectangle 3"/>
-          <p:cNvSpPr/>
-          <p:nvPr/>
-        </p:nvSpPr>
-        <p:spPr>
-          <a:xfrm>
-            <a:off x="201168" y="0"/>
-            <a:ext cx="11990527" cy="411480"/>
-          </a:xfrm>
-          <a:prstGeom prst="rect">
-            <a:avLst/>
-          </a:prstGeom>
-          <a:solidFill>
-            <a:srgbClr val="F6F8FA"/>
-          </a:solidFill>
-          <a:ln>
-            <a:noFill/>
-          </a:ln>
-        </p:spPr>
-        <p:style>
-          <a:lnRef idx="1">
-            <a:schemeClr val="accent1"/>
-          </a:lnRef>
-          <a:fillRef idx="3">
-            <a:schemeClr val="accent1"/>
-          </a:fillRef>
-          <a:effectRef idx="2">
-            <a:schemeClr val="accent1"/>
-          </a:effectRef>
-          <a:fontRef idx="minor">
-            <a:schemeClr val="lt1"/>
-          </a:fontRef>
-        </p:style>
-        <p:txBody>
-          <a:bodyPr rtlCol="0" anchor="ctr"/>
-          <a:lstStyle/>
-          <a:p>
-            <a:pPr algn="ctr"/>
-          </a:p>
-        </p:txBody>
-      </p:sp>
-      <p:sp>
-        <p:nvSpPr>
-          <p:cNvPr id="5" name="TextBox 4"/>
+          <p:cNvPr id="35" name="TextBox 34"/>
           <p:cNvSpPr txBox="1"/>
           <p:nvPr/>
         </p:nvSpPr>
         <p:spPr>
           <a:xfrm>
-            <a:off x="411480" y="73152"/>
-            <a:ext cx="9144000" cy="274320"/>
+            <a:off x="411480" y="6620256"/>
+            <a:ext cx="11430000" cy="228600"/>
           </a:xfrm>
           <a:prstGeom prst="rect">
             <a:avLst/>
@@ -5022,1496 +4652,24 @@
           <a:noFill/>
         </p:spPr>
         <p:txBody>
-          <a:bodyPr wrap="none">
+          <a:bodyPr wrap="square">
             <a:spAutoFit/>
           </a:bodyPr>
           <a:lstStyle/>
           <a:p>
-            <a:pPr>
-              <a:defRPr sz="1100">
+            <a:pPr algn="l">
+              <a:spcAft>
+                <a:spcPts val="200"/>
+              </a:spcAft>
+              <a:defRPr sz="1100" b="0">
                 <a:solidFill>
-                  <a:srgbClr val="5F6E78"/>
+                  <a:srgbClr val="FFFFFF"/>
                 </a:solidFill>
                 <a:latin typeface="Calibri"/>
               </a:defRPr>
             </a:pPr>
             <a:r>
-              <a:t>Fly456  ·  Pre-seed note for Kima Ventures</a:t>
-            </a:r>
-          </a:p>
-        </p:txBody>
-      </p:sp>
-      <p:sp>
-        <p:nvSpPr>
-          <p:cNvPr id="6" name="TextBox 5"/>
-          <p:cNvSpPr txBox="1"/>
-          <p:nvPr/>
-        </p:nvSpPr>
-        <p:spPr>
-          <a:xfrm>
-            <a:off x="11155680" y="73152"/>
-            <a:ext cx="822960" cy="274320"/>
-          </a:xfrm>
-          <a:prstGeom prst="rect">
-            <a:avLst/>
-          </a:prstGeom>
-          <a:noFill/>
-        </p:spPr>
-        <p:txBody>
-          <a:bodyPr wrap="square">
-            <a:spAutoFit/>
-          </a:bodyPr>
-          <a:lstStyle/>
-          <a:p>
-            <a:pPr algn="r">
-              <a:defRPr sz="1100" b="0">
-                <a:solidFill>
-                  <a:srgbClr val="5F6E78"/>
-                </a:solidFill>
-                <a:latin typeface="Calibri"/>
-              </a:defRPr>
-            </a:pPr>
-            <a:r>
-              <a:t>4/6</a:t>
-            </a:r>
-          </a:p>
-        </p:txBody>
-      </p:sp>
-      <p:sp>
-        <p:nvSpPr>
-          <p:cNvPr id="7" name="TextBox 6"/>
-          <p:cNvSpPr txBox="1"/>
-          <p:nvPr/>
-        </p:nvSpPr>
-        <p:spPr>
-          <a:xfrm>
-            <a:off x="457200" y="640080"/>
-            <a:ext cx="10972800" cy="274320"/>
-          </a:xfrm>
-          <a:prstGeom prst="rect">
-            <a:avLst/>
-          </a:prstGeom>
-          <a:noFill/>
-        </p:spPr>
-        <p:txBody>
-          <a:bodyPr wrap="square">
-            <a:spAutoFit/>
-          </a:bodyPr>
-          <a:lstStyle/>
-          <a:p>
-            <a:pPr algn="l">
-              <a:defRPr sz="1200" b="1">
-                <a:solidFill>
-                  <a:srgbClr val="006E82"/>
-                </a:solidFill>
-                <a:latin typeface="Calibri"/>
-              </a:defRPr>
-            </a:pPr>
-            <a:r>
-              <a:t>PRODUCT</a:t>
-            </a:r>
-          </a:p>
-        </p:txBody>
-      </p:sp>
-      <p:sp>
-        <p:nvSpPr>
-          <p:cNvPr id="8" name="TextBox 7"/>
-          <p:cNvSpPr txBox="1"/>
-          <p:nvPr/>
-        </p:nvSpPr>
-        <p:spPr>
-          <a:xfrm>
-            <a:off x="457200" y="960120"/>
-            <a:ext cx="10972800" cy="640080"/>
-          </a:xfrm>
-          <a:prstGeom prst="rect">
-            <a:avLst/>
-          </a:prstGeom>
-          <a:noFill/>
-        </p:spPr>
-        <p:txBody>
-          <a:bodyPr wrap="square">
-            <a:spAutoFit/>
-          </a:bodyPr>
-          <a:lstStyle/>
-          <a:p>
-            <a:pPr algn="l">
-              <a:defRPr sz="2800" b="1">
-                <a:solidFill>
-                  <a:srgbClr val="0F1E2D"/>
-                </a:solidFill>
-                <a:latin typeface="Calibri"/>
-              </a:defRPr>
-            </a:pPr>
-            <a:r>
-              <a:t>Economy and Business — same monitoring, different cabin</a:t>
-            </a:r>
-          </a:p>
-        </p:txBody>
-      </p:sp>
-      <p:sp>
-        <p:nvSpPr>
-          <p:cNvPr id="9" name="Rounded Rectangle 8"/>
-          <p:cNvSpPr/>
-          <p:nvPr/>
-        </p:nvSpPr>
-        <p:spPr>
-          <a:xfrm>
-            <a:off x="457200" y="1828800"/>
-            <a:ext cx="5486400" cy="3840480"/>
-          </a:xfrm>
-          <a:prstGeom prst="roundRect">
-            <a:avLst/>
-          </a:prstGeom>
-          <a:solidFill>
-            <a:srgbClr val="F6F8FA"/>
-          </a:solidFill>
-          <a:ln>
-            <a:noFill/>
-          </a:ln>
-        </p:spPr>
-        <p:style>
-          <a:lnRef idx="1">
-            <a:schemeClr val="accent1"/>
-          </a:lnRef>
-          <a:fillRef idx="3">
-            <a:schemeClr val="accent1"/>
-          </a:fillRef>
-          <a:effectRef idx="2">
-            <a:schemeClr val="accent1"/>
-          </a:effectRef>
-          <a:fontRef idx="minor">
-            <a:schemeClr val="lt1"/>
-          </a:fontRef>
-        </p:style>
-        <p:txBody>
-          <a:bodyPr rtlCol="0" anchor="ctr"/>
-          <a:lstStyle/>
-          <a:p>
-            <a:pPr algn="ctr"/>
-          </a:p>
-        </p:txBody>
-      </p:sp>
-      <p:sp>
-        <p:nvSpPr>
-          <p:cNvPr id="10" name="Rectangle 9"/>
-          <p:cNvSpPr/>
-          <p:nvPr/>
-        </p:nvSpPr>
-        <p:spPr>
-          <a:xfrm>
-            <a:off x="457200" y="1828800"/>
-            <a:ext cx="5486400" cy="54864"/>
-          </a:xfrm>
-          <a:prstGeom prst="rect">
-            <a:avLst/>
-          </a:prstGeom>
-          <a:solidFill>
-            <a:srgbClr val="006E82"/>
-          </a:solidFill>
-          <a:ln>
-            <a:noFill/>
-          </a:ln>
-        </p:spPr>
-        <p:style>
-          <a:lnRef idx="1">
-            <a:schemeClr val="accent1"/>
-          </a:lnRef>
-          <a:fillRef idx="3">
-            <a:schemeClr val="accent1"/>
-          </a:fillRef>
-          <a:effectRef idx="2">
-            <a:schemeClr val="accent1"/>
-          </a:effectRef>
-          <a:fontRef idx="minor">
-            <a:schemeClr val="lt1"/>
-          </a:fontRef>
-        </p:style>
-        <p:txBody>
-          <a:bodyPr rtlCol="0" anchor="ctr"/>
-          <a:lstStyle/>
-          <a:p>
-            <a:pPr algn="ctr"/>
-          </a:p>
-        </p:txBody>
-      </p:sp>
-      <p:sp>
-        <p:nvSpPr>
-          <p:cNvPr id="11" name="TextBox 10"/>
-          <p:cNvSpPr txBox="1"/>
-          <p:nvPr/>
-        </p:nvSpPr>
-        <p:spPr>
-          <a:xfrm>
-            <a:off x="640080" y="2011680"/>
-            <a:ext cx="5120640" cy="320040"/>
-          </a:xfrm>
-          <a:prstGeom prst="rect">
-            <a:avLst/>
-          </a:prstGeom>
-          <a:noFill/>
-        </p:spPr>
-        <p:txBody>
-          <a:bodyPr wrap="square">
-            <a:spAutoFit/>
-          </a:bodyPr>
-          <a:lstStyle/>
-          <a:p>
-            <a:pPr algn="l">
-              <a:defRPr sz="1600" b="1">
-                <a:solidFill>
-                  <a:srgbClr val="0F1E2D"/>
-                </a:solidFill>
-                <a:latin typeface="Calibri"/>
-              </a:defRPr>
-            </a:pPr>
-            <a:r>
-              <a:t>Fly456 Economy</a:t>
-            </a:r>
-          </a:p>
-        </p:txBody>
-      </p:sp>
-      <p:sp>
-        <p:nvSpPr>
-          <p:cNvPr id="12" name="TextBox 11"/>
-          <p:cNvSpPr txBox="1"/>
-          <p:nvPr/>
-        </p:nvSpPr>
-        <p:spPr>
-          <a:xfrm>
-            <a:off x="640080" y="2377440"/>
-            <a:ext cx="5120640" cy="3108960"/>
-          </a:xfrm>
-          <a:prstGeom prst="rect">
-            <a:avLst/>
-          </a:prstGeom>
-          <a:noFill/>
-        </p:spPr>
-        <p:txBody>
-          <a:bodyPr wrap="square">
-            <a:spAutoFit/>
-          </a:bodyPr>
-          <a:lstStyle/>
-          <a:p>
-            <a:pPr>
-              <a:spcAft>
-                <a:spcPts val="400"/>
-              </a:spcAft>
-              <a:defRPr sz="1300">
-                <a:solidFill>
-                  <a:srgbClr val="19232D"/>
-                </a:solidFill>
-                <a:latin typeface="Calibri"/>
-              </a:defRPr>
-            </a:pPr>
-            <a:r>
-              <a:t>Monitors economy-cabin opportunities</a:t>
-            </a:r>
-          </a:p>
-          <a:p>
-            <a:pPr>
-              <a:spcAft>
-                <a:spcPts val="400"/>
-              </a:spcAft>
-              <a:defRPr sz="1300">
-                <a:solidFill>
-                  <a:srgbClr val="19232D"/>
-                </a:solidFill>
-                <a:latin typeface="Calibri"/>
-              </a:defRPr>
-            </a:pPr>
-            <a:r>
-              <a:t>Alert = origin + destination + dates + max price</a:t>
-            </a:r>
-          </a:p>
-          <a:p>
-            <a:pPr>
-              <a:spcAft>
-                <a:spcPts val="400"/>
-              </a:spcAft>
-              <a:defRPr sz="1300">
-                <a:solidFill>
-                  <a:srgbClr val="19232D"/>
-                </a:solidFill>
-                <a:latin typeface="Calibri"/>
-              </a:defRPr>
-            </a:pPr>
-            <a:r>
-              <a:t>Telegram notification when a match appears</a:t>
-            </a:r>
-          </a:p>
-          <a:p>
-            <a:pPr>
-              <a:spcAft>
-                <a:spcPts val="400"/>
-              </a:spcAft>
-              <a:defRPr sz="1300">
-                <a:solidFill>
-                  <a:srgbClr val="19232D"/>
-                </a:solidFill>
-                <a:latin typeface="Calibri"/>
-              </a:defRPr>
-            </a:pPr>
-            <a:r>
-              <a:t>For leisure and price-sensitive travelers</a:t>
-            </a:r>
-          </a:p>
-          <a:p>
-            <a:pPr>
-              <a:spcAft>
-                <a:spcPts val="400"/>
-              </a:spcAft>
-              <a:defRPr sz="1300">
-                <a:solidFill>
-                  <a:srgbClr val="19232D"/>
-                </a:solidFill>
-                <a:latin typeface="Calibri"/>
-              </a:defRPr>
-            </a:pPr>
-            <a:r>
-              <a:t>who need speed, not another search tab</a:t>
-            </a:r>
-          </a:p>
-        </p:txBody>
-      </p:sp>
-      <p:sp>
-        <p:nvSpPr>
-          <p:cNvPr id="13" name="Rounded Rectangle 12"/>
-          <p:cNvSpPr/>
-          <p:nvPr/>
-        </p:nvSpPr>
-        <p:spPr>
-          <a:xfrm>
-            <a:off x="6217920" y="1828800"/>
-            <a:ext cx="5486400" cy="3840480"/>
-          </a:xfrm>
-          <a:prstGeom prst="roundRect">
-            <a:avLst/>
-          </a:prstGeom>
-          <a:solidFill>
-            <a:srgbClr val="F6F8FA"/>
-          </a:solidFill>
-          <a:ln>
-            <a:noFill/>
-          </a:ln>
-        </p:spPr>
-        <p:style>
-          <a:lnRef idx="1">
-            <a:schemeClr val="accent1"/>
-          </a:lnRef>
-          <a:fillRef idx="3">
-            <a:schemeClr val="accent1"/>
-          </a:fillRef>
-          <a:effectRef idx="2">
-            <a:schemeClr val="accent1"/>
-          </a:effectRef>
-          <a:fontRef idx="minor">
-            <a:schemeClr val="lt1"/>
-          </a:fontRef>
-        </p:style>
-        <p:txBody>
-          <a:bodyPr rtlCol="0" anchor="ctr"/>
-          <a:lstStyle/>
-          <a:p>
-            <a:pPr algn="ctr"/>
-          </a:p>
-        </p:txBody>
-      </p:sp>
-      <p:sp>
-        <p:nvSpPr>
-          <p:cNvPr id="14" name="Rectangle 13"/>
-          <p:cNvSpPr/>
-          <p:nvPr/>
-        </p:nvSpPr>
-        <p:spPr>
-          <a:xfrm>
-            <a:off x="6217920" y="1828800"/>
-            <a:ext cx="5486400" cy="54864"/>
-          </a:xfrm>
-          <a:prstGeom prst="rect">
-            <a:avLst/>
-          </a:prstGeom>
-          <a:solidFill>
-            <a:srgbClr val="006E82"/>
-          </a:solidFill>
-          <a:ln>
-            <a:noFill/>
-          </a:ln>
-        </p:spPr>
-        <p:style>
-          <a:lnRef idx="1">
-            <a:schemeClr val="accent1"/>
-          </a:lnRef>
-          <a:fillRef idx="3">
-            <a:schemeClr val="accent1"/>
-          </a:fillRef>
-          <a:effectRef idx="2">
-            <a:schemeClr val="accent1"/>
-          </a:effectRef>
-          <a:fontRef idx="minor">
-            <a:schemeClr val="lt1"/>
-          </a:fontRef>
-        </p:style>
-        <p:txBody>
-          <a:bodyPr rtlCol="0" anchor="ctr"/>
-          <a:lstStyle/>
-          <a:p>
-            <a:pPr algn="ctr"/>
-          </a:p>
-        </p:txBody>
-      </p:sp>
-      <p:sp>
-        <p:nvSpPr>
-          <p:cNvPr id="15" name="TextBox 14"/>
-          <p:cNvSpPr txBox="1"/>
-          <p:nvPr/>
-        </p:nvSpPr>
-        <p:spPr>
-          <a:xfrm>
-            <a:off x="6400800" y="2011680"/>
-            <a:ext cx="5120640" cy="320040"/>
-          </a:xfrm>
-          <a:prstGeom prst="rect">
-            <a:avLst/>
-          </a:prstGeom>
-          <a:noFill/>
-        </p:spPr>
-        <p:txBody>
-          <a:bodyPr wrap="square">
-            <a:spAutoFit/>
-          </a:bodyPr>
-          <a:lstStyle/>
-          <a:p>
-            <a:pPr algn="l">
-              <a:defRPr sz="1600" b="1">
-                <a:solidFill>
-                  <a:srgbClr val="0F1E2D"/>
-                </a:solidFill>
-                <a:latin typeface="Calibri"/>
-              </a:defRPr>
-            </a:pPr>
-            <a:r>
-              <a:t>Fly456 Business</a:t>
-            </a:r>
-          </a:p>
-        </p:txBody>
-      </p:sp>
-      <p:sp>
-        <p:nvSpPr>
-          <p:cNvPr id="16" name="TextBox 15"/>
-          <p:cNvSpPr txBox="1"/>
-          <p:nvPr/>
-        </p:nvSpPr>
-        <p:spPr>
-          <a:xfrm>
-            <a:off x="6400800" y="2377440"/>
-            <a:ext cx="5120640" cy="3108960"/>
-          </a:xfrm>
-          <a:prstGeom prst="rect">
-            <a:avLst/>
-          </a:prstGeom>
-          <a:noFill/>
-        </p:spPr>
-        <p:txBody>
-          <a:bodyPr wrap="square">
-            <a:spAutoFit/>
-          </a:bodyPr>
-          <a:lstStyle/>
-          <a:p>
-            <a:pPr>
-              <a:spcAft>
-                <a:spcPts val="400"/>
-              </a:spcAft>
-              <a:defRPr sz="1300">
-                <a:solidFill>
-                  <a:srgbClr val="19232D"/>
-                </a:solidFill>
-                <a:latin typeface="Calibri"/>
-              </a:defRPr>
-            </a:pPr>
-            <a:r>
-              <a:t>Monitors business-cabin opportunities</a:t>
-            </a:r>
-          </a:p>
-          <a:p>
-            <a:pPr>
-              <a:spcAft>
-                <a:spcPts val="400"/>
-              </a:spcAft>
-              <a:defRPr sz="1300">
-                <a:solidFill>
-                  <a:srgbClr val="19232D"/>
-                </a:solidFill>
-                <a:latin typeface="Calibri"/>
-              </a:defRPr>
-            </a:pPr>
-            <a:r>
-              <a:t>Same named criteria, business fares</a:t>
-            </a:r>
-          </a:p>
-          <a:p>
-            <a:pPr>
-              <a:spcAft>
-                <a:spcPts val="400"/>
-              </a:spcAft>
-              <a:defRPr sz="1300">
-                <a:solidFill>
-                  <a:srgbClr val="19232D"/>
-                </a:solidFill>
-                <a:latin typeface="Calibri"/>
-              </a:defRPr>
-            </a:pPr>
-            <a:r>
-              <a:t>Telegram notification to book fast</a:t>
-            </a:r>
-          </a:p>
-          <a:p>
-            <a:pPr>
-              <a:spcAft>
-                <a:spcPts val="400"/>
-              </a:spcAft>
-              <a:defRPr sz="1300">
-                <a:solidFill>
-                  <a:srgbClr val="19232D"/>
-                </a:solidFill>
-                <a:latin typeface="Calibri"/>
-              </a:defRPr>
-            </a:pPr>
-            <a:r>
-              <a:t>For travelers who want premium cabin</a:t>
-            </a:r>
-          </a:p>
-          <a:p>
-            <a:pPr>
-              <a:spcAft>
-                <a:spcPts val="400"/>
-              </a:spcAft>
-              <a:defRPr sz="1300">
-                <a:solidFill>
-                  <a:srgbClr val="19232D"/>
-                </a:solidFill>
-                <a:latin typeface="Calibri"/>
-              </a:defRPr>
-            </a:pPr>
-            <a:r>
-              <a:t>when the price finally drops into range</a:t>
-            </a:r>
-          </a:p>
-        </p:txBody>
-      </p:sp>
-    </p:spTree>
-  </p:cSld>
-  <p:clrMapOvr>
-    <a:masterClrMapping/>
-  </p:clrMapOvr>
-</p:sld>
-</file>
-
-<file path=ppt/slides/slide5.xml><?xml version="1.0" encoding="utf-8"?>
-<p:sld xmlns:a="http://schemas.openxmlformats.org/drawingml/2006/main" xmlns:p="http://schemas.openxmlformats.org/presentationml/2006/main" xmlns:r="http://schemas.openxmlformats.org/officeDocument/2006/relationships">
-  <p:cSld>
-    <p:spTree>
-      <p:nvGrpSpPr>
-        <p:cNvPr id="1" name=""/>
-        <p:cNvGrpSpPr/>
-        <p:nvPr/>
-      </p:nvGrpSpPr>
-      <p:grpSpPr/>
-      <p:sp>
-        <p:nvSpPr>
-          <p:cNvPr id="2" name="Rectangle 1"/>
-          <p:cNvSpPr/>
-          <p:nvPr/>
-        </p:nvSpPr>
-        <p:spPr>
-          <a:xfrm>
-            <a:off x="0" y="0"/>
-            <a:ext cx="12191695" cy="6858000"/>
-          </a:xfrm>
-          <a:prstGeom prst="rect">
-            <a:avLst/>
-          </a:prstGeom>
-          <a:solidFill>
-            <a:srgbClr val="FFFFFF"/>
-          </a:solidFill>
-          <a:ln>
-            <a:noFill/>
-          </a:ln>
-        </p:spPr>
-        <p:style>
-          <a:lnRef idx="1">
-            <a:schemeClr val="accent1"/>
-          </a:lnRef>
-          <a:fillRef idx="3">
-            <a:schemeClr val="accent1"/>
-          </a:fillRef>
-          <a:effectRef idx="2">
-            <a:schemeClr val="accent1"/>
-          </a:effectRef>
-          <a:fontRef idx="minor">
-            <a:schemeClr val="lt1"/>
-          </a:fontRef>
-        </p:style>
-        <p:txBody>
-          <a:bodyPr rtlCol="0" anchor="ctr"/>
-          <a:lstStyle/>
-          <a:p>
-            <a:pPr algn="ctr"/>
-          </a:p>
-        </p:txBody>
-      </p:sp>
-      <p:sp>
-        <p:nvSpPr>
-          <p:cNvPr id="3" name="Rectangle 2"/>
-          <p:cNvSpPr/>
-          <p:nvPr/>
-        </p:nvSpPr>
-        <p:spPr>
-          <a:xfrm>
-            <a:off x="0" y="0"/>
-            <a:ext cx="201168" cy="6858000"/>
-          </a:xfrm>
-          <a:prstGeom prst="rect">
-            <a:avLst/>
-          </a:prstGeom>
-          <a:solidFill>
-            <a:srgbClr val="006E82"/>
-          </a:solidFill>
-          <a:ln>
-            <a:noFill/>
-          </a:ln>
-        </p:spPr>
-        <p:style>
-          <a:lnRef idx="1">
-            <a:schemeClr val="accent1"/>
-          </a:lnRef>
-          <a:fillRef idx="3">
-            <a:schemeClr val="accent1"/>
-          </a:fillRef>
-          <a:effectRef idx="2">
-            <a:schemeClr val="accent1"/>
-          </a:effectRef>
-          <a:fontRef idx="minor">
-            <a:schemeClr val="lt1"/>
-          </a:fontRef>
-        </p:style>
-        <p:txBody>
-          <a:bodyPr rtlCol="0" anchor="ctr"/>
-          <a:lstStyle/>
-          <a:p>
-            <a:pPr algn="ctr"/>
-          </a:p>
-        </p:txBody>
-      </p:sp>
-      <p:sp>
-        <p:nvSpPr>
-          <p:cNvPr id="4" name="Rectangle 3"/>
-          <p:cNvSpPr/>
-          <p:nvPr/>
-        </p:nvSpPr>
-        <p:spPr>
-          <a:xfrm>
-            <a:off x="201168" y="0"/>
-            <a:ext cx="11990527" cy="411480"/>
-          </a:xfrm>
-          <a:prstGeom prst="rect">
-            <a:avLst/>
-          </a:prstGeom>
-          <a:solidFill>
-            <a:srgbClr val="F6F8FA"/>
-          </a:solidFill>
-          <a:ln>
-            <a:noFill/>
-          </a:ln>
-        </p:spPr>
-        <p:style>
-          <a:lnRef idx="1">
-            <a:schemeClr val="accent1"/>
-          </a:lnRef>
-          <a:fillRef idx="3">
-            <a:schemeClr val="accent1"/>
-          </a:fillRef>
-          <a:effectRef idx="2">
-            <a:schemeClr val="accent1"/>
-          </a:effectRef>
-          <a:fontRef idx="minor">
-            <a:schemeClr val="lt1"/>
-          </a:fontRef>
-        </p:style>
-        <p:txBody>
-          <a:bodyPr rtlCol="0" anchor="ctr"/>
-          <a:lstStyle/>
-          <a:p>
-            <a:pPr algn="ctr"/>
-          </a:p>
-        </p:txBody>
-      </p:sp>
-      <p:sp>
-        <p:nvSpPr>
-          <p:cNvPr id="5" name="TextBox 4"/>
-          <p:cNvSpPr txBox="1"/>
-          <p:nvPr/>
-        </p:nvSpPr>
-        <p:spPr>
-          <a:xfrm>
-            <a:off x="411480" y="73152"/>
-            <a:ext cx="9144000" cy="274320"/>
-          </a:xfrm>
-          <a:prstGeom prst="rect">
-            <a:avLst/>
-          </a:prstGeom>
-          <a:noFill/>
-        </p:spPr>
-        <p:txBody>
-          <a:bodyPr wrap="none">
-            <a:spAutoFit/>
-          </a:bodyPr>
-          <a:lstStyle/>
-          <a:p>
-            <a:pPr>
-              <a:defRPr sz="1100">
-                <a:solidFill>
-                  <a:srgbClr val="5F6E78"/>
-                </a:solidFill>
-                <a:latin typeface="Calibri"/>
-              </a:defRPr>
-            </a:pPr>
-            <a:r>
-              <a:t>Fly456  ·  Pre-seed note for Kima Ventures</a:t>
-            </a:r>
-          </a:p>
-        </p:txBody>
-      </p:sp>
-      <p:sp>
-        <p:nvSpPr>
-          <p:cNvPr id="6" name="TextBox 5"/>
-          <p:cNvSpPr txBox="1"/>
-          <p:nvPr/>
-        </p:nvSpPr>
-        <p:spPr>
-          <a:xfrm>
-            <a:off x="11155680" y="73152"/>
-            <a:ext cx="822960" cy="274320"/>
-          </a:xfrm>
-          <a:prstGeom prst="rect">
-            <a:avLst/>
-          </a:prstGeom>
-          <a:noFill/>
-        </p:spPr>
-        <p:txBody>
-          <a:bodyPr wrap="square">
-            <a:spAutoFit/>
-          </a:bodyPr>
-          <a:lstStyle/>
-          <a:p>
-            <a:pPr algn="r">
-              <a:defRPr sz="1100" b="0">
-                <a:solidFill>
-                  <a:srgbClr val="5F6E78"/>
-                </a:solidFill>
-                <a:latin typeface="Calibri"/>
-              </a:defRPr>
-            </a:pPr>
-            <a:r>
-              <a:t>5/6</a:t>
-            </a:r>
-          </a:p>
-        </p:txBody>
-      </p:sp>
-      <p:sp>
-        <p:nvSpPr>
-          <p:cNvPr id="7" name="TextBox 6"/>
-          <p:cNvSpPr txBox="1"/>
-          <p:nvPr/>
-        </p:nvSpPr>
-        <p:spPr>
-          <a:xfrm>
-            <a:off x="457200" y="640080"/>
-            <a:ext cx="10972800" cy="274320"/>
-          </a:xfrm>
-          <a:prstGeom prst="rect">
-            <a:avLst/>
-          </a:prstGeom>
-          <a:noFill/>
-        </p:spPr>
-        <p:txBody>
-          <a:bodyPr wrap="square">
-            <a:spAutoFit/>
-          </a:bodyPr>
-          <a:lstStyle/>
-          <a:p>
-            <a:pPr algn="l">
-              <a:defRPr sz="1200" b="1">
-                <a:solidFill>
-                  <a:srgbClr val="006E82"/>
-                </a:solidFill>
-                <a:latin typeface="Calibri"/>
-              </a:defRPr>
-            </a:pPr>
-            <a:r>
-              <a:t>TRACTION</a:t>
-            </a:r>
-          </a:p>
-        </p:txBody>
-      </p:sp>
-      <p:sp>
-        <p:nvSpPr>
-          <p:cNvPr id="8" name="TextBox 7"/>
-          <p:cNvSpPr txBox="1"/>
-          <p:nvPr/>
-        </p:nvSpPr>
-        <p:spPr>
-          <a:xfrm>
-            <a:off x="457200" y="960120"/>
-            <a:ext cx="10972800" cy="640080"/>
-          </a:xfrm>
-          <a:prstGeom prst="rect">
-            <a:avLst/>
-          </a:prstGeom>
-          <a:noFill/>
-        </p:spPr>
-        <p:txBody>
-          <a:bodyPr wrap="square">
-            <a:spAutoFit/>
-          </a:bodyPr>
-          <a:lstStyle/>
-          <a:p>
-            <a:pPr algn="l">
-              <a:defRPr sz="2800" b="1">
-                <a:solidFill>
-                  <a:srgbClr val="0F1E2D"/>
-                </a:solidFill>
-                <a:latin typeface="Calibri"/>
-              </a:defRPr>
-            </a:pPr>
-            <a:r>
-              <a:t>Just launched July 2026, no marketing budget</a:t>
-            </a:r>
-          </a:p>
-        </p:txBody>
-      </p:sp>
-      <p:sp>
-        <p:nvSpPr>
-          <p:cNvPr id="9" name="TextBox 8"/>
-          <p:cNvSpPr txBox="1"/>
-          <p:nvPr/>
-        </p:nvSpPr>
-        <p:spPr>
-          <a:xfrm>
-            <a:off x="548640" y="1828800"/>
-            <a:ext cx="10972800" cy="3474720"/>
-          </a:xfrm>
-          <a:prstGeom prst="rect">
-            <a:avLst/>
-          </a:prstGeom>
-          <a:noFill/>
-        </p:spPr>
-        <p:txBody>
-          <a:bodyPr wrap="square">
-            <a:spAutoFit/>
-          </a:bodyPr>
-          <a:lstStyle/>
-          <a:p>
-            <a:pPr>
-              <a:spcAft>
-                <a:spcPts val="1000"/>
-              </a:spcAft>
-              <a:defRPr sz="1700">
-                <a:solidFill>
-                  <a:srgbClr val="19232D"/>
-                </a:solidFill>
-                <a:latin typeface="Calibri"/>
-              </a:defRPr>
-            </a:pPr>
-            <a:r>
-              <a:t>•  Currently 6 free channels live on Telegram for niche audiences (LatAm expats living in EU and US).</a:t>
-            </a:r>
-          </a:p>
-          <a:p>
-            <a:pPr>
-              <a:spcAft>
-                <a:spcPts val="1000"/>
-              </a:spcAft>
-              <a:defRPr sz="1700">
-                <a:solidFill>
-                  <a:srgbClr val="19232D"/>
-                </a:solidFill>
-                <a:latin typeface="Calibri"/>
-              </a:defRPr>
-            </a:pPr>
-            <a:r>
-              <a:t>•  Currently few paying Premium subscribers.</a:t>
-            </a:r>
-          </a:p>
-          <a:p>
-            <a:pPr>
-              <a:spcAft>
-                <a:spcPts val="1000"/>
-              </a:spcAft>
-              <a:defRPr sz="1700">
-                <a:solidFill>
-                  <a:srgbClr val="19232D"/>
-                </a:solidFill>
-                <a:latin typeface="Calibri"/>
-              </a:defRPr>
-            </a:pPr>
-            <a:r>
-              <a:t>•  Plans: Economy 5€/month | 20€/year · Business 12€/month | 99€/year. Stripe checkout in Telegram.</a:t>
-            </a:r>
-          </a:p>
-          <a:p>
-            <a:pPr>
-              <a:spcAft>
-                <a:spcPts val="1000"/>
-              </a:spcAft>
-              <a:defRPr sz="1700">
-                <a:solidFill>
-                  <a:srgbClr val="19232D"/>
-                </a:solidFill>
-                <a:latin typeface="Calibri"/>
-              </a:defRPr>
-            </a:pPr>
-            <a:r>
-              <a:t>•  Product live: fly456.com + @fly456bot</a:t>
-            </a:r>
-          </a:p>
-        </p:txBody>
-      </p:sp>
-      <p:sp>
-        <p:nvSpPr>
-          <p:cNvPr id="10" name="Rounded Rectangle 9"/>
-          <p:cNvSpPr/>
-          <p:nvPr/>
-        </p:nvSpPr>
-        <p:spPr>
-          <a:xfrm>
-            <a:off x="457200" y="5029200"/>
-            <a:ext cx="11247120" cy="1371600"/>
-          </a:xfrm>
-          <a:prstGeom prst="roundRect">
-            <a:avLst/>
-          </a:prstGeom>
-          <a:solidFill>
-            <a:srgbClr val="F6F8FA"/>
-          </a:solidFill>
-          <a:ln>
-            <a:noFill/>
-          </a:ln>
-        </p:spPr>
-        <p:style>
-          <a:lnRef idx="1">
-            <a:schemeClr val="accent1"/>
-          </a:lnRef>
-          <a:fillRef idx="3">
-            <a:schemeClr val="accent1"/>
-          </a:fillRef>
-          <a:effectRef idx="2">
-            <a:schemeClr val="accent1"/>
-          </a:effectRef>
-          <a:fontRef idx="minor">
-            <a:schemeClr val="lt1"/>
-          </a:fontRef>
-        </p:style>
-        <p:txBody>
-          <a:bodyPr rtlCol="0" anchor="ctr"/>
-          <a:lstStyle/>
-          <a:p>
-            <a:pPr algn="ctr"/>
-          </a:p>
-        </p:txBody>
-      </p:sp>
-      <p:sp>
-        <p:nvSpPr>
-          <p:cNvPr id="11" name="Rectangle 10"/>
-          <p:cNvSpPr/>
-          <p:nvPr/>
-        </p:nvSpPr>
-        <p:spPr>
-          <a:xfrm>
-            <a:off x="457200" y="5029200"/>
-            <a:ext cx="11247120" cy="54864"/>
-          </a:xfrm>
-          <a:prstGeom prst="rect">
-            <a:avLst/>
-          </a:prstGeom>
-          <a:solidFill>
-            <a:srgbClr val="006E82"/>
-          </a:solidFill>
-          <a:ln>
-            <a:noFill/>
-          </a:ln>
-        </p:spPr>
-        <p:style>
-          <a:lnRef idx="1">
-            <a:schemeClr val="accent1"/>
-          </a:lnRef>
-          <a:fillRef idx="3">
-            <a:schemeClr val="accent1"/>
-          </a:fillRef>
-          <a:effectRef idx="2">
-            <a:schemeClr val="accent1"/>
-          </a:effectRef>
-          <a:fontRef idx="minor">
-            <a:schemeClr val="lt1"/>
-          </a:fontRef>
-        </p:style>
-        <p:txBody>
-          <a:bodyPr rtlCol="0" anchor="ctr"/>
-          <a:lstStyle/>
-          <a:p>
-            <a:pPr algn="ctr"/>
-          </a:p>
-        </p:txBody>
-      </p:sp>
-      <p:sp>
-        <p:nvSpPr>
-          <p:cNvPr id="12" name="TextBox 11"/>
-          <p:cNvSpPr txBox="1"/>
-          <p:nvPr/>
-        </p:nvSpPr>
-        <p:spPr>
-          <a:xfrm>
-            <a:off x="640080" y="5212080"/>
-            <a:ext cx="10881360" cy="320040"/>
-          </a:xfrm>
-          <a:prstGeom prst="rect">
-            <a:avLst/>
-          </a:prstGeom>
-          <a:noFill/>
-        </p:spPr>
-        <p:txBody>
-          <a:bodyPr wrap="square">
-            <a:spAutoFit/>
-          </a:bodyPr>
-          <a:lstStyle/>
-          <a:p>
-            <a:pPr algn="l">
-              <a:defRPr sz="1600" b="1">
-                <a:solidFill>
-                  <a:srgbClr val="0F1E2D"/>
-                </a:solidFill>
-                <a:latin typeface="Calibri"/>
-              </a:defRPr>
-            </a:pPr>
-            <a:r>
-              <a:t>The ask (~€150k)</a:t>
-            </a:r>
-          </a:p>
-        </p:txBody>
-      </p:sp>
-      <p:sp>
-        <p:nvSpPr>
-          <p:cNvPr id="13" name="TextBox 12"/>
-          <p:cNvSpPr txBox="1"/>
-          <p:nvPr/>
-        </p:nvSpPr>
-        <p:spPr>
-          <a:xfrm>
-            <a:off x="640080" y="5577840"/>
-            <a:ext cx="10881360" cy="640080"/>
-          </a:xfrm>
-          <a:prstGeom prst="rect">
-            <a:avLst/>
-          </a:prstGeom>
-          <a:noFill/>
-        </p:spPr>
-        <p:txBody>
-          <a:bodyPr wrap="square">
-            <a:spAutoFit/>
-          </a:bodyPr>
-          <a:lstStyle/>
-          <a:p>
-            <a:pPr>
-              <a:spcAft>
-                <a:spcPts val="400"/>
-              </a:spcAft>
-              <a:defRPr sz="1300">
-                <a:solidFill>
-                  <a:srgbClr val="19232D"/>
-                </a:solidFill>
-                <a:latin typeface="Calibri"/>
-              </a:defRPr>
-            </a:pPr>
-            <a:r>
-              <a:t>Sharper monitoring · faster Telegram alerts · grow paid Economy + Business · keep burn low</a:t>
-            </a:r>
-          </a:p>
-        </p:txBody>
-      </p:sp>
-    </p:spTree>
-  </p:cSld>
-  <p:clrMapOvr>
-    <a:masterClrMapping/>
-  </p:clrMapOvr>
-</p:sld>
-</file>
-
-<file path=ppt/slides/slide6.xml><?xml version="1.0" encoding="utf-8"?>
-<p:sld xmlns:a="http://schemas.openxmlformats.org/drawingml/2006/main" xmlns:p="http://schemas.openxmlformats.org/presentationml/2006/main" xmlns:r="http://schemas.openxmlformats.org/officeDocument/2006/relationships">
-  <p:cSld>
-    <p:spTree>
-      <p:nvGrpSpPr>
-        <p:cNvPr id="1" name=""/>
-        <p:cNvGrpSpPr/>
-        <p:nvPr/>
-      </p:nvGrpSpPr>
-      <p:grpSpPr/>
-      <p:sp>
-        <p:nvSpPr>
-          <p:cNvPr id="2" name="Rectangle 1"/>
-          <p:cNvSpPr/>
-          <p:nvPr/>
-        </p:nvSpPr>
-        <p:spPr>
-          <a:xfrm>
-            <a:off x="0" y="0"/>
-            <a:ext cx="12191695" cy="6858000"/>
-          </a:xfrm>
-          <a:prstGeom prst="rect">
-            <a:avLst/>
-          </a:prstGeom>
-          <a:solidFill>
-            <a:srgbClr val="FFFFFF"/>
-          </a:solidFill>
-          <a:ln>
-            <a:noFill/>
-          </a:ln>
-        </p:spPr>
-        <p:style>
-          <a:lnRef idx="1">
-            <a:schemeClr val="accent1"/>
-          </a:lnRef>
-          <a:fillRef idx="3">
-            <a:schemeClr val="accent1"/>
-          </a:fillRef>
-          <a:effectRef idx="2">
-            <a:schemeClr val="accent1"/>
-          </a:effectRef>
-          <a:fontRef idx="minor">
-            <a:schemeClr val="lt1"/>
-          </a:fontRef>
-        </p:style>
-        <p:txBody>
-          <a:bodyPr rtlCol="0" anchor="ctr"/>
-          <a:lstStyle/>
-          <a:p>
-            <a:pPr algn="ctr"/>
-          </a:p>
-        </p:txBody>
-      </p:sp>
-      <p:sp>
-        <p:nvSpPr>
-          <p:cNvPr id="3" name="Rectangle 2"/>
-          <p:cNvSpPr/>
-          <p:nvPr/>
-        </p:nvSpPr>
-        <p:spPr>
-          <a:xfrm>
-            <a:off x="0" y="0"/>
-            <a:ext cx="201168" cy="6858000"/>
-          </a:xfrm>
-          <a:prstGeom prst="rect">
-            <a:avLst/>
-          </a:prstGeom>
-          <a:solidFill>
-            <a:srgbClr val="006E82"/>
-          </a:solidFill>
-          <a:ln>
-            <a:noFill/>
-          </a:ln>
-        </p:spPr>
-        <p:style>
-          <a:lnRef idx="1">
-            <a:schemeClr val="accent1"/>
-          </a:lnRef>
-          <a:fillRef idx="3">
-            <a:schemeClr val="accent1"/>
-          </a:fillRef>
-          <a:effectRef idx="2">
-            <a:schemeClr val="accent1"/>
-          </a:effectRef>
-          <a:fontRef idx="minor">
-            <a:schemeClr val="lt1"/>
-          </a:fontRef>
-        </p:style>
-        <p:txBody>
-          <a:bodyPr rtlCol="0" anchor="ctr"/>
-          <a:lstStyle/>
-          <a:p>
-            <a:pPr algn="ctr"/>
-          </a:p>
-        </p:txBody>
-      </p:sp>
-      <p:sp>
-        <p:nvSpPr>
-          <p:cNvPr id="4" name="Rectangle 3"/>
-          <p:cNvSpPr/>
-          <p:nvPr/>
-        </p:nvSpPr>
-        <p:spPr>
-          <a:xfrm>
-            <a:off x="201168" y="0"/>
-            <a:ext cx="11990527" cy="411480"/>
-          </a:xfrm>
-          <a:prstGeom prst="rect">
-            <a:avLst/>
-          </a:prstGeom>
-          <a:solidFill>
-            <a:srgbClr val="F6F8FA"/>
-          </a:solidFill>
-          <a:ln>
-            <a:noFill/>
-          </a:ln>
-        </p:spPr>
-        <p:style>
-          <a:lnRef idx="1">
-            <a:schemeClr val="accent1"/>
-          </a:lnRef>
-          <a:fillRef idx="3">
-            <a:schemeClr val="accent1"/>
-          </a:fillRef>
-          <a:effectRef idx="2">
-            <a:schemeClr val="accent1"/>
-          </a:effectRef>
-          <a:fontRef idx="minor">
-            <a:schemeClr val="lt1"/>
-          </a:fontRef>
-        </p:style>
-        <p:txBody>
-          <a:bodyPr rtlCol="0" anchor="ctr"/>
-          <a:lstStyle/>
-          <a:p>
-            <a:pPr algn="ctr"/>
-          </a:p>
-        </p:txBody>
-      </p:sp>
-      <p:sp>
-        <p:nvSpPr>
-          <p:cNvPr id="5" name="TextBox 4"/>
-          <p:cNvSpPr txBox="1"/>
-          <p:nvPr/>
-        </p:nvSpPr>
-        <p:spPr>
-          <a:xfrm>
-            <a:off x="411480" y="73152"/>
-            <a:ext cx="9144000" cy="274320"/>
-          </a:xfrm>
-          <a:prstGeom prst="rect">
-            <a:avLst/>
-          </a:prstGeom>
-          <a:noFill/>
-        </p:spPr>
-        <p:txBody>
-          <a:bodyPr wrap="none">
-            <a:spAutoFit/>
-          </a:bodyPr>
-          <a:lstStyle/>
-          <a:p>
-            <a:pPr>
-              <a:defRPr sz="1100">
-                <a:solidFill>
-                  <a:srgbClr val="5F6E78"/>
-                </a:solidFill>
-                <a:latin typeface="Calibri"/>
-              </a:defRPr>
-            </a:pPr>
-            <a:r>
-              <a:t>Fly456  ·  Pre-seed note for Kima Ventures</a:t>
-            </a:r>
-          </a:p>
-        </p:txBody>
-      </p:sp>
-      <p:sp>
-        <p:nvSpPr>
-          <p:cNvPr id="6" name="TextBox 5"/>
-          <p:cNvSpPr txBox="1"/>
-          <p:nvPr/>
-        </p:nvSpPr>
-        <p:spPr>
-          <a:xfrm>
-            <a:off x="11155680" y="73152"/>
-            <a:ext cx="822960" cy="274320"/>
-          </a:xfrm>
-          <a:prstGeom prst="rect">
-            <a:avLst/>
-          </a:prstGeom>
-          <a:noFill/>
-        </p:spPr>
-        <p:txBody>
-          <a:bodyPr wrap="square">
-            <a:spAutoFit/>
-          </a:bodyPr>
-          <a:lstStyle/>
-          <a:p>
-            <a:pPr algn="r">
-              <a:defRPr sz="1100" b="0">
-                <a:solidFill>
-                  <a:srgbClr val="5F6E78"/>
-                </a:solidFill>
-                <a:latin typeface="Calibri"/>
-              </a:defRPr>
-            </a:pPr>
-            <a:r>
-              <a:t>6/6</a:t>
-            </a:r>
-          </a:p>
-        </p:txBody>
-      </p:sp>
-      <p:sp>
-        <p:nvSpPr>
-          <p:cNvPr id="7" name="TextBox 6"/>
-          <p:cNvSpPr txBox="1"/>
-          <p:nvPr/>
-        </p:nvSpPr>
-        <p:spPr>
-          <a:xfrm>
-            <a:off x="457200" y="640080"/>
-            <a:ext cx="10972800" cy="274320"/>
-          </a:xfrm>
-          <a:prstGeom prst="rect">
-            <a:avLst/>
-          </a:prstGeom>
-          <a:noFill/>
-        </p:spPr>
-        <p:txBody>
-          <a:bodyPr wrap="square">
-            <a:spAutoFit/>
-          </a:bodyPr>
-          <a:lstStyle/>
-          <a:p>
-            <a:pPr algn="l">
-              <a:defRPr sz="1200" b="1">
-                <a:solidFill>
-                  <a:srgbClr val="006E82"/>
-                </a:solidFill>
-                <a:latin typeface="Calibri"/>
-              </a:defRPr>
-            </a:pPr>
-            <a:r>
-              <a:t>TEAM</a:t>
-            </a:r>
-          </a:p>
-        </p:txBody>
-      </p:sp>
-      <p:sp>
-        <p:nvSpPr>
-          <p:cNvPr id="8" name="TextBox 7"/>
-          <p:cNvSpPr txBox="1"/>
-          <p:nvPr/>
-        </p:nvSpPr>
-        <p:spPr>
-          <a:xfrm>
-            <a:off x="457200" y="960120"/>
-            <a:ext cx="10972800" cy="640080"/>
-          </a:xfrm>
-          <a:prstGeom prst="rect">
-            <a:avLst/>
-          </a:prstGeom>
-          <a:noFill/>
-        </p:spPr>
-        <p:txBody>
-          <a:bodyPr wrap="square">
-            <a:spAutoFit/>
-          </a:bodyPr>
-          <a:lstStyle/>
-          <a:p>
-            <a:pPr algn="l">
-              <a:defRPr sz="2800" b="1">
-                <a:solidFill>
-                  <a:srgbClr val="0F1E2D"/>
-                </a:solidFill>
-                <a:latin typeface="Calibri"/>
-              </a:defRPr>
-            </a:pPr>
-            <a:r>
-              <a:t>Operator-builder shipping the full loop</a:t>
-            </a:r>
-          </a:p>
-        </p:txBody>
-      </p:sp>
-      <p:sp>
-        <p:nvSpPr>
-          <p:cNvPr id="9" name="TextBox 8"/>
-          <p:cNvSpPr txBox="1"/>
-          <p:nvPr/>
-        </p:nvSpPr>
-        <p:spPr>
-          <a:xfrm>
-            <a:off x="548640" y="1828800"/>
-            <a:ext cx="10972800" cy="3657600"/>
-          </a:xfrm>
-          <a:prstGeom prst="rect">
-            <a:avLst/>
-          </a:prstGeom>
-          <a:noFill/>
-        </p:spPr>
-        <p:txBody>
-          <a:bodyPr wrap="square">
-            <a:spAutoFit/>
-          </a:bodyPr>
-          <a:lstStyle/>
-          <a:p>
-            <a:pPr>
-              <a:spcAft>
-                <a:spcPts val="1000"/>
-              </a:spcAft>
-              <a:defRPr sz="1800">
-                <a:solidFill>
-                  <a:srgbClr val="19232D"/>
-                </a:solidFill>
-                <a:latin typeface="Calibri"/>
-              </a:defRPr>
-            </a:pPr>
-            <a:r>
-              <a:t>•  Emiliano Tichauer — Founder</a:t>
-            </a:r>
-          </a:p>
-          <a:p>
-            <a:pPr>
-              <a:spcAft>
-                <a:spcPts val="1000"/>
-              </a:spcAft>
-              <a:defRPr sz="1800">
-                <a:solidFill>
-                  <a:srgbClr val="19232D"/>
-                </a:solidFill>
-                <a:latin typeface="Calibri"/>
-              </a:defRPr>
-            </a:pPr>
-            <a:r>
-              <a:t>•  Built Parvus Media since 2013 (AdTech, data, performance products)</a:t>
-            </a:r>
-          </a:p>
-          <a:p>
-            <a:pPr>
-              <a:spcAft>
-                <a:spcPts val="1000"/>
-              </a:spcAft>
-              <a:defRPr sz="1800">
-                <a:solidFill>
-                  <a:srgbClr val="19232D"/>
-                </a:solidFill>
-                <a:latin typeface="Calibri"/>
-              </a:defRPr>
-            </a:pPr>
-            <a:r>
-              <a:t>•  Owns the loop end-to-end: flight monitoring, Telegram UX, Stripe billing</a:t>
-            </a:r>
-          </a:p>
-          <a:p>
-            <a:pPr>
-              <a:spcAft>
-                <a:spcPts val="1000"/>
-              </a:spcAft>
-              <a:defRPr sz="1800">
-                <a:solidFill>
-                  <a:srgbClr val="19232D"/>
-                </a:solidFill>
-                <a:latin typeface="Calibri"/>
-              </a:defRPr>
-            </a:pPr>
-            <a:r>
-              <a:t>•  Contact: [email]  ·  LinkedIn: linkedin.com/in/etichauer  ·  fly456.com</a:t>
+              <a:t>Emiliano Tichauer — Founder  ·  emiliano@tichauer.es  ·  linkedin.com/in/etichauer  ·  fly456.com</a:t>
             </a:r>
           </a:p>
         </p:txBody>

</xml_diff>

<commit_message>
Highlight expat niche as recurring flight buyers on one-pager.
Also drop LTV/CAC claim from use of funds; keep honest early traction.

Co-authored-by: Emiliano Tichauer <Parvusmedia@users.noreply.github.com>
</commit_message>
<xml_diff>
--- a/Fly456_Kima_OnePager.pptx
+++ b/Fly456_Kima_OnePager.pptx
@@ -3623,7 +3623,7 @@
               </a:defRPr>
             </a:pPr>
             <a:r>
-              <a:t>• When you finally see it, the fare is often gone.</a:t>
+              <a:t>• Expats buy flights again and again (home, family, season) — missing one fare hurts every trip.</a:t>
             </a:r>
           </a:p>
         </p:txBody>
@@ -4375,7 +4375,7 @@
               </a:defRPr>
             </a:pPr>
             <a:r>
-              <a:t>• Early Premium — few paying subscribers so far.</a:t>
+              <a:t>• Expats are recurring flight buyers (home visits, family, season).</a:t>
             </a:r>
           </a:p>
           <a:p>
@@ -4391,7 +4391,7 @@
               </a:defRPr>
             </a:pPr>
             <a:r>
-              <a:t>• Live: fly456.com + @fly456bot (Stripe in Telegram).</a:t>
+              <a:t>• Early Premium — few paying so far. Live: fly456.com + @fly456bot.</a:t>
             </a:r>
           </a:p>
         </p:txBody>
@@ -4555,7 +4555,7 @@
               </a:defRPr>
             </a:pPr>
             <a:r>
-              <a:t>• BizDev hire  ·  paid acquisition tests</a:t>
+              <a:t>• BizDev hire  ·  light paid acquisition tests</a:t>
             </a:r>
           </a:p>
           <a:p>
@@ -4571,7 +4571,7 @@
               </a:defRPr>
             </a:pPr>
             <a:r>
-              <a:t>• Free → Premium conversion  ·  affiliate pilots</a:t>
+              <a:t>• Free → Premium conversion</a:t>
             </a:r>
           </a:p>
           <a:p>
@@ -4587,7 +4587,7 @@
               </a:defRPr>
             </a:pPr>
             <a:r>
-              <a:t>• Prove LTV/CAC with low burn</a:t>
+              <a:t>• Affiliate / partner pilots</a:t>
             </a:r>
           </a:p>
         </p:txBody>

</xml_diff>